<commit_message>
Simplify deck methodology and add plain-language reading guides
Methods rewritten without formula-first framing: 'two straight lines and a
kink' in three steps, the two-doors Kaya explanation, plain eligibility
rules, and the five-step treaty-credit ladder in words. Every figure slide
now carries a 'How to read it' line explaining the encoding and what to
notice, written for readers unfamiliar with breakpoint methods.

Co-Authored-By: Claude Fable 5 <noreply@anthropic.com>
Claude-Session: https://claude.ai/code/session_012bL1neYjCv63DshXztLcAg
</commit_message>
<xml_diff>
--- a/carbon_breakpoints_takeaway_figures/what_bends_the_curve_final.pptx
+++ b/carbon_breakpoints_takeaway_figures/what_bends_the_curve_final.pptx
@@ -593,7 +593,7 @@
           <a:lstStyle/>
           <a:p>
             <a:r>
-              <a:t>This is the hinge of the talk: the non-attribution is not a failure of Paris — it is the reason the analysis must descend to the national level, where attribution machinery actually has power.</a:t>
+              <a:t>The hinge of the talk: the non-attribution is not a failure of Paris — it is the reason the analysis must descend to the national level, where attribution machinery has power.</a:t>
             </a:r>
           </a:p>
         </p:txBody>
@@ -663,7 +663,7 @@
           <a:lstStyle/>
           <a:p>
             <a:r>
-              <a:t>No common treaty era: breaks scatter 1970–2013 and pile up around oil shocks, post-Cold-War upheaval, crises, and the renewables era. Bottom: among 71 documented episodes, events sit near the estimated breaks far more often than restricted random dates allow (45% vs 17% within 2 years; 80% vs 37% within 5; 70% vs 33% inside the episode) — the historical classifications carry real temporal information.</a:t>
+              <a:t>No common treaty era: breaks scatter 1970–2013 and pile up around oil shocks, post-Cold-War upheaval, crises, and the renewables era. Event alignment: 45% vs 17% within 2 years; 80% vs 37% within 5; 70% vs 33% inside the episode.</a:t>
             </a:r>
           </a:p>
         </p:txBody>
@@ -733,7 +733,7 @@
           <a:lstStyle/>
           <a:p>
             <a:r>
-              <a:t>One square per country. Fuel and energy markets 22, restructuring 18, political disruption 11, macro shocks 9, development and access 6 — and climate policy with low-carbon technology in 9 of 97. 22 remain honestly unresolved. Mechanisms are structured author-coded interpretations against documentary sources — not causal estimates.</a:t>
+              <a:t>Fuel and energy markets 22, restructuring 18, political disruption 11, macro shocks 9, development and access 6, policy 9, unresolved 22. Author-coded against authoritative sources with a stopping rule — interpretations, not causal estimates.</a:t>
             </a:r>
           </a:p>
         </p:txBody>
@@ -873,7 +873,7 @@
           <a:lstStyle/>
           <a:p>
             <a:r>
-              <a:t>Shocks flow into contraction; restructuring often ends in 'intensity gain, CO2 rising'. Only nine countries end in constructive persistent decarbonization. The gray band on the left axis is the distinct 22 with no attributed mechanism.</a:t>
+              <a:t>Shocks flow into contraction; restructuring often ends in 'intensity gain, CO2 rising'. Only nine countries end in constructive persistent decarbonization.</a:t>
             </a:r>
           </a:p>
         </p:txBody>
@@ -943,7 +943,7 @@
           <a:lstStyle/>
           <a:p>
             <a:r>
-              <a:t>Raw quadrant counts: 55 favorable bends coincide with still-rising CO2; only 19 with falling CO2. The stricter quality classification — adding persistence and mechanism — narrows these to 12 improving-but-rising and 9 constructive. Green triangles are the 9 policy-enabled cases: Bhutan and Paraguay improve intensity while absolute emissions still rise — policy-enabled and constructive overlap but are not identical.</a:t>
+              <a:t>Raw counts: 55 favorable bends with rising CO2; 19 with falling CO2. The stricter classification narrows these to 12 and 9. Green triangles: the 9 policy-enabled cases — Bhutan and Paraguay improve intensity while emissions still rise, so policy-enabled and constructive are overlapping but different sets.</a:t>
             </a:r>
           </a:p>
         </p:txBody>
@@ -1013,7 +1013,7 @@
           <a:lstStyle/>
           <a:p>
             <a:r>
-              <a:t>The defining test: intensity AND absolute CO2 both fall after the break. Six of nine are policy-enabled; Hungary, Nauru, and Ireland arrived via restructuring. Caveat: Nauru is a micro-state whose 'restructuring' is the phosphate collapse — treat with care. This is the paper's constructive core: policy made physical in fuel mix, infrastructure, and economic structure.</a:t>
+              <a:t>Six of nine are policy-enabled; Hungary, Nauru, and Ireland arrived via restructuring. Caveat: Nauru is a micro-state whose 'restructuring' is the phosphate collapse — treat with care.</a:t>
             </a:r>
           </a:p>
         </p:txBody>
@@ -1083,7 +1083,7 @@
           <a:lstStyle/>
           <a:p>
             <a:r>
-              <a:t>Three routes around the constructive verdict: fuel substitution (5), evidence limits (4), collapse (1). Netherlands 1975 is gas-substitution decarbonization forty years before the US shale version. Somalia 1985 is the caution: collapse mimics decarbonization in every raw statistic; only the persistence screen catches it. Even genuine emission-cutters span 1975–2012 — no treaty era here either.</a:t>
+              <a:t>Routes around the constructive verdict: fuel substitution (5), evidence limits (4), collapse (1). Netherlands 1975: gas substitution forty years before US shale. Somalia 1985: collapse mimics decarbonization in every raw statistic; only the persistence screen catches it. Breaks span 1975–2012 — no treaty era here either.</a:t>
             </a:r>
           </a:p>
         </p:txBody>
@@ -1153,7 +1153,7 @@
           <a:lstStyle/>
           <a:p>
             <a:r>
-              <a:t>Left: primary mechanism by country — fuel-market transformations cluster in the Americas and MENA, restructuring across Asia-Pacific, policy-enabled cases in northern Europe. Right: transition quality — dark-green outlines mark the nine; much of the map is contraction, incompleteness, or intensity gains overwhelmed by growth.</a:t>
+              <a:t>Fuel-market transformations cluster in the Americas and MENA; restructuring across Asia-Pacific; policy-enabled cases in northern Europe. Right: much of the map is contraction, incompleteness, or intensity gains overwhelmed by growth.</a:t>
             </a:r>
           </a:p>
         </p:txBody>
@@ -1223,7 +1223,7 @@
           <a:lstStyle/>
           <a:p>
             <a:r>
-              <a:t>Policy-enabled cases rank high on independent assessments: median CAT percentile ~64 vs 34 for other classified breaks; CCPI ~91 vs 44. But CAT covers only 3 of the 9 and CCPI 2 — every covered country is shown as a dot so the thin coverage is visible. Corroborative, not definitive.</a:t>
+              <a:t>Median CAT percentile ~64 vs 34; CCPI ~91 vs 44. Corroborative, not definitive.</a:t>
             </a:r>
           </a:p>
         </p:txBody>
@@ -1433,7 +1433,7 @@
           <a:lstStyle/>
           <a:p>
             <a:r>
-              <a:t>97 eligible breaks classified by realized transition quality — and none of this heterogeneity aligns on a treaty date. The treaty question dissolves into 97 national stories; nine end in unambiguous decarbonization.</a:t>
+              <a:t>None of this heterogeneity aligns on a treaty date. The treaty question dissolves into 97 national stories; nine end in unambiguous decarbonization.</a:t>
             </a:r>
           </a:p>
         </p:txBody>
@@ -1503,7 +1503,7 @@
           <a:lstStyle/>
           <a:p>
             <a:r>
-              <a:t>End on the closing line and the four-part method signature. If one sentence survives the talk, it is this one.</a:t>
+              <a:t>End on the closing line and the four-part method signature.</a:t>
             </a:r>
           </a:p>
         </p:txBody>
@@ -1573,7 +1573,7 @@
           <a:lstStyle/>
           <a:p>
             <a:r>
-              <a:t>One methods slide on the estimator, one on the sample. Emphasize: 'when, not why' — the design lock's central discipline.</a:t>
+              <a:t>Keep this conversational: two lines and a kink, tried at every year; then shake the data to see if the date holds still. The 'two doors' framing sets up the mechanism logic used throughout Acts II-III.</a:t>
             </a:r>
           </a:p>
         </p:txBody>
@@ -1643,7 +1643,7 @@
           <a:lstStyle/>
           <a:p>
             <a:r>
-              <a:t>The funnel figure is from the current deck. The five-step ladder is the frozen attribution standard — it returns in Act I applied to Paris itself.</a:t>
+              <a:t>The placebo idea in one line: a significant result at the treaty year means little if 1990 and 1994 are just as 'significant'. The ladder is the paper's discipline — and Act I applies it to Paris.</a:t>
             </a:r>
           </a:p>
         </p:txBody>
@@ -1713,7 +1713,7 @@
           <a:lstStyle/>
           <a:p>
             <a:r>
-              <a:t>Act I is reframed relative to earlier drafts: not 'treaties failed' but 'the record shows a real recent acceleration whose timing cannot yet separate Paris from the renewables cost decline.'</a:t>
+              <a:t>Act I is reframed: not 'treaties failed' but 'the record shows a real recent acceleration whose timing cannot yet separate Paris from the renewables cost decline.'</a:t>
             </a:r>
           </a:p>
         </p:txBody>
@@ -1783,7 +1783,7 @@
           <a:lstStyle/>
           <a:p>
             <a:r>
-              <a:t>C/GDP breaks ~1973, E/GDP ~1974 — the oil-shock era. C/E's point estimate is 1992 but its interval spans 1978–2011: it does not uniquely identify Rio. Multiple-break models show several episodes, not one intervention. Robust to consumption-based emissions, excluding former Soviet economies, PPP GDP.</a:t>
+              <a:t>C/GDP breaks ~1973, E/GDP ~1974 — the oil-shock era. C/E's point estimate is 1992 but its interval spans 1978–2011: it does not uniquely identify Rio. Robust to consumption-based emissions, excluding former Soviet economies, PPP GDP.</a:t>
             </a:r>
           </a:p>
         </p:txBody>
@@ -1853,7 +1853,7 @@
           <a:lstStyle/>
           <a:p>
             <a:r>
-              <a:t>The post-2015 points fall below the extrapolated Rio-to-Paris trend: a real supply-side acceleration (C/E −0.7 pp/yr, NW t=4.3; C/GDP −0.9, t=2.9). But onsets from 2011–2016 fit the full record about equally well (best 2013), and E/GDP shows no acceleration. So the acceleration is what an effective Paris should look like — and it cannot yet be separated from the renewables cost collapse that preceded the treaty.</a:t>
+              <a:t>A real supply-side acceleration (C/E −0.7 pp/yr, NW t=4.3; C/GDP −0.9, t=2.9). But onsets from 2011–2016 fit the full record about equally well (best 2013), and E/GDP shows no acceleration. What an effective Paris should look like — and not yet separable from the renewables cost collapse that preceded the treaty.</a:t>
             </a:r>
           </a:p>
         </p:txBody>
@@ -1923,7 +1923,7 @@
           <a:lstStyle/>
           <a:p>
             <a:r>
-              <a:t>Kaya growth accounting by era. Emissions growth slowed from +2.1 to +0.4%/yr after 2015 — but roughly two-thirds of the slowdown is slower GDP growth; one-third is the cleaner fuel mix. The dotted line marks the intensity decline needed to hold emissions flat: the world is still short of it.</a:t>
+              <a:t>Emissions growth slowed from +2.1 to +0.4%/yr after 2015 — but roughly two-thirds of the slowdown is slower GDP growth; one-third is the cleaner fuel mix. The gap to the dotted line is the remaining task.</a:t>
             </a:r>
           </a:p>
         </p:txBody>
@@ -1993,7 +1993,7 @@
           <a:lstStyle/>
           <a:p>
             <a:r>
-              <a:t>Top: the model-fit profile across candidate break years is a plateau — why a significant treaty-year hinge is weak evidence alone. Bottom: the evidentiary funnel. Nominal treaty-date significance is common (48–69% of series); date-uniqueness is rare (Rio: 10 C/GDP, 21 C/E, 34 E/GDP series; Paris: 14, 5, 6). Applied to Paris's own decade, the same discipline dates the global acceleration's onset to ~2013.</a:t>
+              <a:t>Nominal treaty-date significance is common (48–69% of series); date-uniqueness is rare (Rio: 10/21/34 series by component; Paris: 14/5/6). The same discipline applied to Paris's decade dates the global acceleration's onset to ~2013.</a:t>
             </a:r>
           </a:p>
         </p:txBody>
@@ -5059,7 +5059,7 @@
               </a:spcAft>
             </a:pPr>
             <a:r>
-              <a:rPr sz="1500" b="1">
+              <a:rPr sz="1500" b="1" i="0">
                 <a:solidFill>
                   <a:srgbClr val="1B7837"/>
                 </a:solidFill>
@@ -5098,7 +5098,7 @@
               </a:spcAft>
             </a:pPr>
             <a:r>
-              <a:rPr sz="1350" b="1">
+              <a:rPr sz="1350" b="1" i="0">
                 <a:solidFill>
                   <a:srgbClr val="212121"/>
                 </a:solidFill>
@@ -5107,7 +5107,7 @@
               <a:t>204 jurisdictions     </a:t>
             </a:r>
             <a:r>
-              <a:rPr sz="1350" b="1">
+              <a:rPr sz="1350" b="1" i="0">
                 <a:solidFill>
                   <a:srgbClr val="212121"/>
                 </a:solidFill>
@@ -5116,7 +5116,7 @@
               <a:t>97 eligible national breaks     </a:t>
             </a:r>
             <a:r>
-              <a:rPr sz="1350" b="1">
+              <a:rPr sz="1350" b="1" i="0">
                 <a:solidFill>
                   <a:srgbClr val="212121"/>
                 </a:solidFill>
@@ -5125,7 +5125,7 @@
               <a:t>7 mechanism families     </a:t>
             </a:r>
             <a:r>
-              <a:rPr sz="1350" b="1">
+              <a:rPr sz="1350" b="1" i="0">
                 <a:solidFill>
                   <a:srgbClr val="1B7837"/>
                 </a:solidFill>
@@ -5162,8 +5162,8 @@
         </p:nvSpPr>
         <p:spPr>
           <a:xfrm>
-            <a:off x="502920" y="256032"/>
-            <a:ext cx="11201400" cy="1051560"/>
+            <a:off x="502920" y="274320"/>
+            <a:ext cx="11201400" cy="914400"/>
           </a:xfrm>
           <a:prstGeom prst="rect">
             <a:avLst/>
@@ -5198,7 +5198,7 @@
               </a:spcAft>
             </a:pPr>
             <a:r>
-              <a:rPr sz="2700" b="1" i="0">
+              <a:rPr sz="2400" b="1" i="0">
                 <a:solidFill>
                   <a:srgbClr val="212121"/>
                 </a:solidFill>
@@ -5253,7 +5253,7 @@
               </a:spcAft>
             </a:pPr>
             <a:r>
-              <a:rPr sz="1350" b="1">
+              <a:rPr sz="1350" b="1" i="0">
                 <a:solidFill>
                   <a:srgbClr val="1B7837"/>
                 </a:solidFill>
@@ -5262,13 +5262,13 @@
               <a:t>•  </a:t>
             </a:r>
             <a:r>
-              <a:rPr sz="1350" b="0">
+              <a:rPr sz="1350" b="0" i="0">
                 <a:solidFill>
                   <a:srgbClr val="555555"/>
                 </a:solidFill>
                 <a:latin typeface="Calibri"/>
               </a:rPr>
-              <a:t>A real post-2013 supply-side acceleration: C/E falling −0.5%/yr after a flat quarter-century; C/GDP −0.9 pp/yr faster than the Rio-to-Paris trend (Newey–West).</a:t>
+              <a:t>A real post-2013 supply-side acceleration: the fuel mix is improving −0.5%/yr after a flat quarter-century; overall intensity is falling ~0.9 pp/yr faster than its Rio-to-Paris trend.</a:t>
             </a:r>
           </a:p>
           <a:p>
@@ -5278,7 +5278,7 @@
               </a:spcAft>
             </a:pPr>
             <a:r>
-              <a:rPr sz="1350" b="1">
+              <a:rPr sz="1350" b="1" i="0">
                 <a:solidFill>
                   <a:srgbClr val="1B7837"/>
                 </a:solidFill>
@@ -5287,7 +5287,7 @@
               <a:t>•  </a:t>
             </a:r>
             <a:r>
-              <a:rPr sz="1350" b="0">
+              <a:rPr sz="1350" b="0" i="0">
                 <a:solidFill>
                   <a:srgbClr val="555555"/>
                 </a:solidFill>
@@ -5303,7 +5303,7 @@
               </a:spcAft>
             </a:pPr>
             <a:r>
-              <a:rPr sz="1350" b="1">
+              <a:rPr sz="1350" b="1" i="0">
                 <a:solidFill>
                   <a:srgbClr val="1B7837"/>
                 </a:solidFill>
@@ -5312,13 +5312,13 @@
               <a:t>•  </a:t>
             </a:r>
             <a:r>
-              <a:rPr sz="1350" b="0">
+              <a:rPr sz="1350" b="0" i="0">
                 <a:solidFill>
                   <a:srgbClr val="555555"/>
                 </a:solidFill>
                 <a:latin typeface="Calibri"/>
               </a:rPr>
-              <a:t>No acceleration on the demand side (E/GDP): efficiency and structure continue their 50-year trend.</a:t>
+              <a:t>No acceleration on the demand side: energy efficiency continues its 50-year trend, no faster.</a:t>
             </a:r>
           </a:p>
         </p:txBody>
@@ -5367,7 +5367,7 @@
               </a:spcAft>
             </a:pPr>
             <a:r>
-              <a:rPr sz="1350" b="1">
+              <a:rPr sz="1350" b="1" i="0">
                 <a:solidFill>
                   <a:srgbClr val="B33A3A"/>
                 </a:solidFill>
@@ -5376,13 +5376,13 @@
               <a:t>•  </a:t>
             </a:r>
             <a:r>
-              <a:rPr sz="1350" b="0">
+              <a:rPr sz="1350" b="0" i="0">
                 <a:solidFill>
                   <a:srgbClr val="555555"/>
                 </a:solidFill>
                 <a:latin typeface="Calibri"/>
               </a:rPr>
-              <a:t>Timing: candidate onsets 2011–2016 fit about equally well (best 2013) — indistinguishable from the renewables cost collapse that preceded Paris.</a:t>
+              <a:t>Timing: start years from 2011 to 2016 fit about equally well (best: 2013) — indistinguishable from the renewables cost collapse that preceded Paris.</a:t>
             </a:r>
           </a:p>
           <a:p>
@@ -5392,7 +5392,7 @@
               </a:spcAft>
             </a:pPr>
             <a:r>
-              <a:rPr sz="1350" b="1">
+              <a:rPr sz="1350" b="1" i="0">
                 <a:solidFill>
                   <a:srgbClr val="B33A3A"/>
                 </a:solidFill>
@@ -5401,13 +5401,13 @@
               <a:t>•  </a:t>
             </a:r>
             <a:r>
-              <a:rPr sz="1350" b="0">
+              <a:rPr sz="1350" b="0" i="0">
                 <a:solidFill>
                   <a:srgbClr val="555555"/>
                 </a:solidFill>
                 <a:latin typeface="Calibri"/>
               </a:rPr>
-              <a:t>Power: with 8 post-Paris years, only an acceleration ≈0.8 pp/yr is detectable at 80% power — Paris would have had to double a 50-year trend to prove itself already.</a:t>
+              <a:t>Power: with only 8 post-Paris years, we could only detect a very large acceleration — Paris would have had to double a 50-year trend to prove itself already.</a:t>
             </a:r>
           </a:p>
           <a:p>
@@ -5417,7 +5417,7 @@
               </a:spcAft>
             </a:pPr>
             <a:r>
-              <a:rPr sz="1350" b="1">
+              <a:rPr sz="1350" b="1" i="0">
                 <a:solidFill>
                   <a:srgbClr val="B33A3A"/>
                 </a:solidFill>
@@ -5426,7 +5426,7 @@
               <a:t>•  </a:t>
             </a:r>
             <a:r>
-              <a:rPr sz="1350" b="0">
+              <a:rPr sz="1350" b="0" i="0">
                 <a:solidFill>
                   <a:srgbClr val="555555"/>
                 </a:solidFill>
@@ -5442,7 +5442,7 @@
               </a:spcAft>
             </a:pPr>
             <a:r>
-              <a:rPr sz="1350" b="1">
+              <a:rPr sz="1350" b="1" i="0">
                 <a:solidFill>
                   <a:srgbClr val="B33A3A"/>
                 </a:solidFill>
@@ -5451,13 +5451,13 @@
               <a:t>•  </a:t>
             </a:r>
             <a:r>
-              <a:rPr sz="1350" b="0">
+              <a:rPr sz="1350" b="0" i="0">
                 <a:solidFill>
                   <a:srgbClr val="555555"/>
                 </a:solidFill>
                 <a:latin typeface="Calibri"/>
               </a:rPr>
-              <a:t>Design: Paris works through NDCs and national transformation — its signature should appear country by country. So we look there.</a:t>
+              <a:t>Design: Paris works through national pledges and national transformation — its signature should appear country by country. So we look there.</a:t>
             </a:r>
           </a:p>
         </p:txBody>
@@ -5488,8 +5488,8 @@
         </p:nvSpPr>
         <p:spPr>
           <a:xfrm>
-            <a:off x="502920" y="256032"/>
-            <a:ext cx="11201400" cy="1051560"/>
+            <a:off x="502920" y="274320"/>
+            <a:ext cx="11201400" cy="914400"/>
           </a:xfrm>
           <a:prstGeom prst="rect">
             <a:avLst/>
@@ -5524,20 +5524,68 @@
               </a:spcAft>
             </a:pPr>
             <a:r>
-              <a:rPr sz="2700" b="1" i="0">
+              <a:rPr sz="2400" b="1" i="0">
                 <a:solidFill>
                   <a:srgbClr val="212121"/>
                 </a:solidFill>
                 <a:latin typeface="Calibri"/>
               </a:rPr>
-              <a:t>97 national breaks across five decades — tracking economic history</a:t>
+              <a:t>97 national breaks, five decades of economic history</a:t>
+            </a:r>
+          </a:p>
+        </p:txBody>
+      </p:sp>
+      <p:sp>
+        <p:nvSpPr>
+          <p:cNvPr id="3" name="TextBox 2"/>
+          <p:cNvSpPr txBox="1"/>
+          <p:nvPr/>
+        </p:nvSpPr>
+        <p:spPr>
+          <a:xfrm>
+            <a:off x="502920" y="1207008"/>
+            <a:ext cx="11201400" cy="603504"/>
+          </a:xfrm>
+          <a:prstGeom prst="rect">
+            <a:avLst/>
+          </a:prstGeom>
+          <a:noFill/>
+        </p:spPr>
+        <p:txBody>
+          <a:bodyPr wrap="square">
+            <a:spAutoFit/>
+          </a:bodyPr>
+          <a:lstStyle/>
+          <a:p>
+            <a:pPr algn="l">
+              <a:spcAft>
+                <a:spcPts val="0"/>
+              </a:spcAft>
+            </a:pPr>
+            <a:r>
+              <a:rPr sz="1250" b="1" i="0">
+                <a:solidFill>
+                  <a:srgbClr val="3A66A5"/>
+                </a:solidFill>
+                <a:latin typeface="Calibri"/>
+              </a:rPr>
+              <a:t>How to read it:  </a:t>
+            </a:r>
+            <a:r>
+              <a:rPr sz="1250" b="0" i="0">
+                <a:solidFill>
+                  <a:srgbClr val="555555"/>
+                </a:solidFill>
+                <a:latin typeface="Calibri"/>
+              </a:rPr>
+              <a:t>Top: each dot is one country, placed at its estimated break year; green triangles are the nine policy-enabled cases. Shaded bands mark major economic and political episodes; Rio and Paris are the two dashed lines. Bottom: how often a documented historical event falls near a country's break (red) versus what randomly chosen years would produce (blue).</a:t>
             </a:r>
           </a:p>
         </p:txBody>
       </p:sp>
       <p:pic>
         <p:nvPicPr>
-          <p:cNvPr id="3" name="Picture 2" descr="takeaway_fig03_when_and_why_curves_bend.png"/>
+          <p:cNvPr id="4" name="Picture 3" descr="takeaway_fig03_when_and_why_curves_bend.png"/>
           <p:cNvPicPr>
             <a:picLocks noChangeAspect="1"/>
           </p:cNvPicPr>
@@ -5551,8 +5599,8 @@
         </p:blipFill>
         <p:spPr>
           <a:xfrm>
-            <a:off x="2760116" y="1325880"/>
-            <a:ext cx="6668719" cy="5129783"/>
+            <a:off x="3015691" y="1865376"/>
+            <a:ext cx="6157569" cy="4736592"/>
           </a:xfrm>
           <a:prstGeom prst="rect">
             <a:avLst/>
@@ -5585,8 +5633,8 @@
         </p:nvSpPr>
         <p:spPr>
           <a:xfrm>
-            <a:off x="502920" y="256032"/>
-            <a:ext cx="11201400" cy="1051560"/>
+            <a:off x="502920" y="274320"/>
+            <a:ext cx="11201400" cy="914400"/>
           </a:xfrm>
           <a:prstGeom prst="rect">
             <a:avLst/>
@@ -5621,20 +5669,68 @@
               </a:spcAft>
             </a:pPr>
             <a:r>
-              <a:rPr sz="2700" b="1" i="0">
+              <a:rPr sz="2400" b="1" i="0">
                 <a:solidFill>
                   <a:srgbClr val="212121"/>
                 </a:solidFill>
                 <a:latin typeface="Calibri"/>
               </a:rPr>
-              <a:t>What accompanied the bends: mostly markets, restructuring, disruption</a:t>
+              <a:t>What accompanied the bends</a:t>
+            </a:r>
+          </a:p>
+        </p:txBody>
+      </p:sp>
+      <p:sp>
+        <p:nvSpPr>
+          <p:cNvPr id="3" name="TextBox 2"/>
+          <p:cNvSpPr txBox="1"/>
+          <p:nvPr/>
+        </p:nvSpPr>
+        <p:spPr>
+          <a:xfrm>
+            <a:off x="502920" y="1207008"/>
+            <a:ext cx="11201400" cy="603504"/>
+          </a:xfrm>
+          <a:prstGeom prst="rect">
+            <a:avLst/>
+          </a:prstGeom>
+          <a:noFill/>
+        </p:spPr>
+        <p:txBody>
+          <a:bodyPr wrap="square">
+            <a:spAutoFit/>
+          </a:bodyPr>
+          <a:lstStyle/>
+          <a:p>
+            <a:pPr algn="l">
+              <a:spcAft>
+                <a:spcPts val="0"/>
+              </a:spcAft>
+            </a:pPr>
+            <a:r>
+              <a:rPr sz="1250" b="1" i="0">
+                <a:solidFill>
+                  <a:srgbClr val="3A66A5"/>
+                </a:solidFill>
+                <a:latin typeface="Calibri"/>
+              </a:rPr>
+              <a:t>How to read it:  </a:t>
+            </a:r>
+            <a:r>
+              <a:rPr sz="1250" b="0" i="0">
+                <a:solidFill>
+                  <a:srgbClr val="555555"/>
+                </a:solidFill>
+                <a:latin typeface="Calibri"/>
+              </a:rPr>
+              <a:t>One square per country, grouped by the historical process best supported by documentary evidence around its break. Green marks the countries where climate policy and low-carbon technology are that best-supported process; light gray means the record cannot yet explain the break — reported honestly rather than forced into a category.</a:t>
             </a:r>
           </a:p>
         </p:txBody>
       </p:sp>
       <p:pic>
         <p:nvPicPr>
-          <p:cNvPr id="3" name="Picture 2" descr="takeaway_fig04_mechanism_census.png"/>
+          <p:cNvPr id="4" name="Picture 3" descr="takeaway_fig04_mechanism_census.png"/>
           <p:cNvPicPr>
             <a:picLocks noChangeAspect="1"/>
           </p:cNvPicPr>
@@ -5648,8 +5744,8 @@
         </p:blipFill>
         <p:spPr>
           <a:xfrm>
-            <a:off x="787802" y="1325880"/>
-            <a:ext cx="10613346" cy="5129783"/>
+            <a:off x="1194553" y="1865376"/>
+            <a:ext cx="9799845" cy="4736592"/>
           </a:xfrm>
           <a:prstGeom prst="rect">
             <a:avLst/>
@@ -5682,8 +5778,8 @@
         </p:nvSpPr>
         <p:spPr>
           <a:xfrm>
-            <a:off x="502920" y="256032"/>
-            <a:ext cx="11201400" cy="1051560"/>
+            <a:off x="502920" y="274320"/>
+            <a:ext cx="11201400" cy="914400"/>
           </a:xfrm>
           <a:prstGeom prst="rect">
             <a:avLst/>
@@ -5718,7 +5814,7 @@
               </a:spcAft>
             </a:pPr>
             <a:r>
-              <a:rPr sz="2700" b="1" i="0">
+              <a:rPr sz="2400" b="1" i="0">
                 <a:solidFill>
                   <a:srgbClr val="212121"/>
                 </a:solidFill>
@@ -5773,7 +5869,7 @@
               </a:spcAft>
             </a:pPr>
             <a:r>
-              <a:rPr sz="1200" b="1">
+              <a:rPr sz="1200" b="1" i="0">
                 <a:solidFill>
                   <a:srgbClr val="212121"/>
                 </a:solidFill>
@@ -5782,7 +5878,7 @@
               <a:t>Policy-enabled low carbon — </a:t>
             </a:r>
             <a:r>
-              <a:rPr sz="1200" b="0">
+              <a:rPr sz="1200" b="0" i="0">
                 <a:solidFill>
                   <a:srgbClr val="555555"/>
                 </a:solidFill>
@@ -5798,7 +5894,7 @@
               </a:spcAft>
             </a:pPr>
             <a:r>
-              <a:rPr sz="1200" b="1">
+              <a:rPr sz="1200" b="1" i="0">
                 <a:solidFill>
                   <a:srgbClr val="212121"/>
                 </a:solidFill>
@@ -5807,7 +5903,7 @@
               <a:t>Fuel &amp; energy markets — </a:t>
             </a:r>
             <a:r>
-              <a:rPr sz="1200" b="0">
+              <a:rPr sz="1200" b="0" i="0">
                 <a:solidFill>
                   <a:srgbClr val="555555"/>
                 </a:solidFill>
@@ -5823,7 +5919,7 @@
               </a:spcAft>
             </a:pPr>
             <a:r>
-              <a:rPr sz="1200" b="1">
+              <a:rPr sz="1200" b="1" i="0">
                 <a:solidFill>
                   <a:srgbClr val="212121"/>
                 </a:solidFill>
@@ -5832,7 +5928,7 @@
               <a:t>Economic restructuring — </a:t>
             </a:r>
             <a:r>
-              <a:rPr sz="1200" b="0">
+              <a:rPr sz="1200" b="0" i="0">
                 <a:solidFill>
                   <a:srgbClr val="555555"/>
                 </a:solidFill>
@@ -5848,7 +5944,7 @@
               </a:spcAft>
             </a:pPr>
             <a:r>
-              <a:rPr sz="1200" b="1">
+              <a:rPr sz="1200" b="1" i="0">
                 <a:solidFill>
                   <a:srgbClr val="212121"/>
                 </a:solidFill>
@@ -5857,7 +5953,7 @@
               <a:t>Macroeconomic shock — </a:t>
             </a:r>
             <a:r>
-              <a:rPr sz="1200" b="0">
+              <a:rPr sz="1200" b="0" i="0">
                 <a:solidFill>
                   <a:srgbClr val="555555"/>
                 </a:solidFill>
@@ -5873,7 +5969,7 @@
               </a:spcAft>
             </a:pPr>
             <a:r>
-              <a:rPr sz="1200" b="1">
+              <a:rPr sz="1200" b="1" i="0">
                 <a:solidFill>
                   <a:srgbClr val="212121"/>
                 </a:solidFill>
@@ -5882,7 +5978,7 @@
               <a:t>Political disruption — </a:t>
             </a:r>
             <a:r>
-              <a:rPr sz="1200" b="0">
+              <a:rPr sz="1200" b="0" i="0">
                 <a:solidFill>
                   <a:srgbClr val="555555"/>
                 </a:solidFill>
@@ -5898,7 +5994,7 @@
               </a:spcAft>
             </a:pPr>
             <a:r>
-              <a:rPr sz="1200" b="1">
+              <a:rPr sz="1200" b="1" i="0">
                 <a:solidFill>
                   <a:srgbClr val="212121"/>
                 </a:solidFill>
@@ -5907,7 +6003,7 @@
               <a:t>Development &amp; energy access — </a:t>
             </a:r>
             <a:r>
-              <a:rPr sz="1200" b="0">
+              <a:rPr sz="1200" b="0" i="0">
                 <a:solidFill>
                   <a:srgbClr val="555555"/>
                 </a:solidFill>
@@ -5923,7 +6019,7 @@
               </a:spcAft>
             </a:pPr>
             <a:r>
-              <a:rPr sz="1200" b="1">
+              <a:rPr sz="1200" b="1" i="0">
                 <a:solidFill>
                   <a:srgbClr val="212121"/>
                 </a:solidFill>
@@ -5932,7 +6028,7 @@
               <a:t>No attributed mechanism — </a:t>
             </a:r>
             <a:r>
-              <a:rPr sz="1200" b="0">
+              <a:rPr sz="1200" b="0" i="0">
                 <a:solidFill>
                   <a:srgbClr val="555555"/>
                 </a:solidFill>
@@ -5993,7 +6089,7 @@
                 </a:solidFill>
                 <a:latin typeface="Calibri"/>
               </a:rPr>
-              <a:t>favorable? persistent? absolute CO2 falling? constructive mechanism?</a:t>
+              <a:t>Did the trend improve? Did it last? Did absolute CO2 actually fall? Was the underlying process constructive?</a:t>
             </a:r>
           </a:p>
           <a:p>
@@ -6003,7 +6099,7 @@
               </a:spcAft>
             </a:pPr>
             <a:r>
-              <a:rPr sz="1200" b="1">
+              <a:rPr sz="1200" b="1" i="0">
                 <a:solidFill>
                   <a:srgbClr val="212121"/>
                 </a:solidFill>
@@ -6012,7 +6108,7 @@
               <a:t>Constructive persistent decarbonization </a:t>
             </a:r>
             <a:r>
-              <a:rPr sz="1200" b="1">
+              <a:rPr sz="1200" b="1" i="0">
                 <a:solidFill>
                   <a:srgbClr val="1B7837"/>
                 </a:solidFill>
@@ -6021,7 +6117,7 @@
               <a:t>(9) — </a:t>
             </a:r>
             <a:r>
-              <a:rPr sz="1200" b="0">
+              <a:rPr sz="1200" b="0" i="0">
                 <a:solidFill>
                   <a:srgbClr val="555555"/>
                 </a:solidFill>
@@ -6037,7 +6133,7 @@
               </a:spcAft>
             </a:pPr>
             <a:r>
-              <a:rPr sz="1200" b="1">
+              <a:rPr sz="1200" b="1" i="0">
                 <a:solidFill>
                   <a:srgbClr val="212121"/>
                 </a:solidFill>
@@ -6046,7 +6142,7 @@
               <a:t>Persistent fuel substitution </a:t>
             </a:r>
             <a:r>
-              <a:rPr sz="1200" b="1">
+              <a:rPr sz="1200" b="1" i="0">
                 <a:solidFill>
                   <a:srgbClr val="8A8A8A"/>
                 </a:solidFill>
@@ -6055,7 +6151,7 @@
               <a:t>(13) — </a:t>
             </a:r>
             <a:r>
-              <a:rPr sz="1200" b="0">
+              <a:rPr sz="1200" b="0" i="0">
                 <a:solidFill>
                   <a:srgbClr val="555555"/>
                 </a:solidFill>
@@ -6071,7 +6167,7 @@
               </a:spcAft>
             </a:pPr>
             <a:r>
-              <a:rPr sz="1200" b="1">
+              <a:rPr sz="1200" b="1" i="0">
                 <a:solidFill>
                   <a:srgbClr val="212121"/>
                 </a:solidFill>
@@ -6080,7 +6176,7 @@
               <a:t>Intensity gain; CO2 still rising </a:t>
             </a:r>
             <a:r>
-              <a:rPr sz="1200" b="1">
+              <a:rPr sz="1200" b="1" i="0">
                 <a:solidFill>
                   <a:srgbClr val="8A8A8A"/>
                 </a:solidFill>
@@ -6089,7 +6185,7 @@
               <a:t>(12) — </a:t>
             </a:r>
             <a:r>
-              <a:rPr sz="1200" b="0">
+              <a:rPr sz="1200" b="0" i="0">
                 <a:solidFill>
                   <a:srgbClr val="555555"/>
                 </a:solidFill>
@@ -6105,7 +6201,7 @@
               </a:spcAft>
             </a:pPr>
             <a:r>
-              <a:rPr sz="1200" b="1">
+              <a:rPr sz="1200" b="1" i="0">
                 <a:solidFill>
                   <a:srgbClr val="212121"/>
                 </a:solidFill>
@@ -6114,7 +6210,7 @@
               <a:t>Contractionary / disruptive </a:t>
             </a:r>
             <a:r>
-              <a:rPr sz="1200" b="1">
+              <a:rPr sz="1200" b="1" i="0">
                 <a:solidFill>
                   <a:srgbClr val="8A8A8A"/>
                 </a:solidFill>
@@ -6123,7 +6219,7 @@
               <a:t>(20) — </a:t>
             </a:r>
             <a:r>
-              <a:rPr sz="1200" b="0">
+              <a:rPr sz="1200" b="0" i="0">
                 <a:solidFill>
                   <a:srgbClr val="555555"/>
                 </a:solidFill>
@@ -6139,7 +6235,7 @@
               </a:spcAft>
             </a:pPr>
             <a:r>
-              <a:rPr sz="1200" b="1">
+              <a:rPr sz="1200" b="1" i="0">
                 <a:solidFill>
                   <a:srgbClr val="212121"/>
                 </a:solidFill>
@@ -6148,7 +6244,7 @@
               <a:t>Incomplete / nonpersistent </a:t>
             </a:r>
             <a:r>
-              <a:rPr sz="1200" b="1">
+              <a:rPr sz="1200" b="1" i="0">
                 <a:solidFill>
                   <a:srgbClr val="8A8A8A"/>
                 </a:solidFill>
@@ -6157,7 +6253,7 @@
               <a:t>(21) — </a:t>
             </a:r>
             <a:r>
-              <a:rPr sz="1200" b="0">
+              <a:rPr sz="1200" b="0" i="0">
                 <a:solidFill>
                   <a:srgbClr val="555555"/>
                 </a:solidFill>
@@ -6173,7 +6269,7 @@
               </a:spcAft>
             </a:pPr>
             <a:r>
-              <a:rPr sz="1200" b="1">
+              <a:rPr sz="1200" b="1" i="0">
                 <a:solidFill>
                   <a:srgbClr val="212121"/>
                 </a:solidFill>
@@ -6182,7 +6278,7 @@
               <a:t>Outcome not classifiable </a:t>
             </a:r>
             <a:r>
-              <a:rPr sz="1200" b="1">
+              <a:rPr sz="1200" b="1" i="0">
                 <a:solidFill>
                   <a:srgbClr val="8A8A8A"/>
                 </a:solidFill>
@@ -6191,7 +6287,7 @@
               <a:t>(22) — </a:t>
             </a:r>
             <a:r>
-              <a:rPr sz="1200" b="0">
+              <a:rPr sz="1200" b="0" i="0">
                 <a:solidFill>
                   <a:srgbClr val="555555"/>
                 </a:solidFill>
@@ -6228,8 +6324,8 @@
         </p:nvSpPr>
         <p:spPr>
           <a:xfrm>
-            <a:off x="502920" y="256032"/>
-            <a:ext cx="11201400" cy="1051560"/>
+            <a:off x="502920" y="274320"/>
+            <a:ext cx="11201400" cy="914400"/>
           </a:xfrm>
           <a:prstGeom prst="rect">
             <a:avLst/>
@@ -6250,7 +6346,7 @@
             <a:r>
               <a:rPr sz="1200" b="1" i="0">
                 <a:solidFill>
-                  <a:srgbClr val="1B7837"/>
+                  <a:srgbClr val="C77F00"/>
                 </a:solidFill>
                 <a:latin typeface="Calibri"/>
               </a:rPr>
@@ -6264,20 +6360,68 @@
               </a:spcAft>
             </a:pPr>
             <a:r>
-              <a:rPr sz="2700" b="1" i="0">
+              <a:rPr sz="2400" b="1" i="0">
                 <a:solidFill>
                   <a:srgbClr val="212121"/>
                 </a:solidFill>
                 <a:latin typeface="Calibri"/>
               </a:rPr>
-              <a:t>From mechanism to verdict: 97 countries flow to six outcomes</a:t>
+              <a:t>From mechanism to verdict: 97 countries, six outcomes</a:t>
+            </a:r>
+          </a:p>
+        </p:txBody>
+      </p:sp>
+      <p:sp>
+        <p:nvSpPr>
+          <p:cNvPr id="3" name="TextBox 2"/>
+          <p:cNvSpPr txBox="1"/>
+          <p:nvPr/>
+        </p:nvSpPr>
+        <p:spPr>
+          <a:xfrm>
+            <a:off x="502920" y="1207008"/>
+            <a:ext cx="11201400" cy="603504"/>
+          </a:xfrm>
+          <a:prstGeom prst="rect">
+            <a:avLst/>
+          </a:prstGeom>
+          <a:noFill/>
+        </p:spPr>
+        <p:txBody>
+          <a:bodyPr wrap="square">
+            <a:spAutoFit/>
+          </a:bodyPr>
+          <a:lstStyle/>
+          <a:p>
+            <a:pPr algn="l">
+              <a:spcAft>
+                <a:spcPts val="0"/>
+              </a:spcAft>
+            </a:pPr>
+            <a:r>
+              <a:rPr sz="1250" b="1" i="0">
+                <a:solidFill>
+                  <a:srgbClr val="3A66A5"/>
+                </a:solidFill>
+                <a:latin typeface="Calibri"/>
+              </a:rPr>
+              <a:t>How to read it:  </a:t>
+            </a:r>
+            <a:r>
+              <a:rPr sz="1250" b="0" i="0">
+                <a:solidFill>
+                  <a:srgbClr val="555555"/>
+                </a:solidFill>
+                <a:latin typeface="Calibri"/>
+              </a:rPr>
+              <a:t>Each ribbon carries countries from the process that accompanied their break (left) to how the outcome is judged (right); ribbon width is the number of countries. Follow any left-hand category to see where those transitions actually ended up.</a:t>
             </a:r>
           </a:p>
         </p:txBody>
       </p:sp>
       <p:pic>
         <p:nvPicPr>
-          <p:cNvPr id="3" name="Picture 2" descr="image4.png"/>
+          <p:cNvPr id="4" name="Picture 3" descr="image4.png"/>
           <p:cNvPicPr>
             <a:picLocks noChangeAspect="1"/>
           </p:cNvPicPr>
@@ -6291,8 +6435,8 @@
         </p:blipFill>
         <p:spPr>
           <a:xfrm>
-            <a:off x="2473452" y="1325880"/>
-            <a:ext cx="7242047" cy="5129783"/>
+            <a:off x="2750999" y="1865376"/>
+            <a:ext cx="6686953" cy="4736592"/>
           </a:xfrm>
           <a:prstGeom prst="rect">
             <a:avLst/>
@@ -6325,8 +6469,8 @@
         </p:nvSpPr>
         <p:spPr>
           <a:xfrm>
-            <a:off x="502920" y="256032"/>
-            <a:ext cx="11201400" cy="1051560"/>
+            <a:off x="502920" y="274320"/>
+            <a:ext cx="11201400" cy="914400"/>
           </a:xfrm>
           <a:prstGeom prst="rect">
             <a:avLst/>
@@ -6347,7 +6491,7 @@
             <a:r>
               <a:rPr sz="1200" b="1" i="0">
                 <a:solidFill>
-                  <a:srgbClr val="1B7837"/>
+                  <a:srgbClr val="C77F00"/>
                 </a:solidFill>
                 <a:latin typeface="Calibri"/>
               </a:rPr>
@@ -6361,20 +6505,68 @@
               </a:spcAft>
             </a:pPr>
             <a:r>
-              <a:rPr sz="2700" b="1" i="0">
+              <a:rPr sz="2400" b="1" i="0">
                 <a:solidFill>
                   <a:srgbClr val="212121"/>
                 </a:solidFill>
                 <a:latin typeface="Calibri"/>
               </a:rPr>
-              <a:t>Lower carbon intensity is not the same as falling emissions</a:t>
+              <a:t>Lower intensity is not the same as falling emissions</a:t>
+            </a:r>
+          </a:p>
+        </p:txBody>
+      </p:sp>
+      <p:sp>
+        <p:nvSpPr>
+          <p:cNvPr id="3" name="TextBox 2"/>
+          <p:cNvSpPr txBox="1"/>
+          <p:nvPr/>
+        </p:nvSpPr>
+        <p:spPr>
+          <a:xfrm>
+            <a:off x="502920" y="1207008"/>
+            <a:ext cx="11201400" cy="603504"/>
+          </a:xfrm>
+          <a:prstGeom prst="rect">
+            <a:avLst/>
+          </a:prstGeom>
+          <a:noFill/>
+        </p:spPr>
+        <p:txBody>
+          <a:bodyPr wrap="square">
+            <a:spAutoFit/>
+          </a:bodyPr>
+          <a:lstStyle/>
+          <a:p>
+            <a:pPr algn="l">
+              <a:spcAft>
+                <a:spcPts val="0"/>
+              </a:spcAft>
+            </a:pPr>
+            <a:r>
+              <a:rPr sz="1250" b="1" i="0">
+                <a:solidFill>
+                  <a:srgbClr val="3A66A5"/>
+                </a:solidFill>
+                <a:latin typeface="Calibri"/>
+              </a:rPr>
+              <a:t>How to read it:  </a:t>
+            </a:r>
+            <a:r>
+              <a:rPr sz="1250" b="0" i="0">
+                <a:solidFill>
+                  <a:srgbClr val="555555"/>
+                </a:solidFill>
+                <a:latin typeface="Calibri"/>
+              </a:rPr>
+              <a:t>Each dot is a country. Further right means its intensity trend improved more after the break; below the dashed horizontal line means absolute emissions are actually falling. Success lives only in the lower right — and most improving countries sit above the line, where growth still outruns their gains.</a:t>
             </a:r>
           </a:p>
         </p:txBody>
       </p:sp>
       <p:pic>
         <p:nvPicPr>
-          <p:cNvPr id="3" name="Picture 2" descr="takeaway_fig05_bend_vs_success.png"/>
+          <p:cNvPr id="4" name="Picture 3" descr="takeaway_fig05_bend_vs_success.png"/>
           <p:cNvPicPr>
             <a:picLocks noChangeAspect="1"/>
           </p:cNvPicPr>
@@ -6388,8 +6580,8 @@
         </p:blipFill>
         <p:spPr>
           <a:xfrm>
-            <a:off x="2247138" y="1325880"/>
-            <a:ext cx="7694675" cy="5129783"/>
+            <a:off x="2542032" y="1865376"/>
+            <a:ext cx="7104888" cy="4736592"/>
           </a:xfrm>
           <a:prstGeom prst="rect">
             <a:avLst/>
@@ -6422,8 +6614,8 @@
         </p:nvSpPr>
         <p:spPr>
           <a:xfrm>
-            <a:off x="502920" y="256032"/>
-            <a:ext cx="11201400" cy="1051560"/>
+            <a:off x="502920" y="274320"/>
+            <a:ext cx="11201400" cy="914400"/>
           </a:xfrm>
           <a:prstGeom prst="rect">
             <a:avLst/>
@@ -6444,7 +6636,7 @@
             <a:r>
               <a:rPr sz="1200" b="1" i="0">
                 <a:solidFill>
-                  <a:srgbClr val="1B7837"/>
+                  <a:srgbClr val="C77F00"/>
                 </a:solidFill>
                 <a:latin typeface="Calibri"/>
               </a:rPr>
@@ -6458,7 +6650,7 @@
               </a:spcAft>
             </a:pPr>
             <a:r>
-              <a:rPr sz="2700" b="1" i="0">
+              <a:rPr sz="2400" b="1" i="0">
                 <a:solidFill>
                   <a:srgbClr val="212121"/>
                 </a:solidFill>
@@ -6478,7 +6670,7 @@
         <p:spPr>
           <a:xfrm>
             <a:off x="502920" y="1207008"/>
-            <a:ext cx="11201400" cy="411480"/>
+            <a:ext cx="11201400" cy="384048"/>
           </a:xfrm>
           <a:prstGeom prst="rect">
             <a:avLst/>
@@ -6497,20 +6689,68 @@
               </a:spcAft>
             </a:pPr>
             <a:r>
-              <a:rPr sz="1350" b="0" i="0">
+              <a:rPr sz="1300" b="1" i="0">
+                <a:solidFill>
+                  <a:srgbClr val="212121"/>
+                </a:solidFill>
+                <a:latin typeface="Calibri"/>
+              </a:rPr>
+              <a:t>Sweden 1986 · Finland 1993 · Hungary 1996 · Switzerland 1999 · Nauru 1999 · Denmark 2002 · Portugal 2004 · United Kingdom 2010 · Ireland 2012</a:t>
+            </a:r>
+          </a:p>
+        </p:txBody>
+      </p:sp>
+      <p:sp>
+        <p:nvSpPr>
+          <p:cNvPr id="4" name="TextBox 3"/>
+          <p:cNvSpPr txBox="1"/>
+          <p:nvPr/>
+        </p:nvSpPr>
+        <p:spPr>
+          <a:xfrm>
+            <a:off x="502920" y="1609344"/>
+            <a:ext cx="11201400" cy="603504"/>
+          </a:xfrm>
+          <a:prstGeom prst="rect">
+            <a:avLst/>
+          </a:prstGeom>
+          <a:noFill/>
+        </p:spPr>
+        <p:txBody>
+          <a:bodyPr wrap="square">
+            <a:spAutoFit/>
+          </a:bodyPr>
+          <a:lstStyle/>
+          <a:p>
+            <a:pPr algn="l">
+              <a:spcAft>
+                <a:spcPts val="0"/>
+              </a:spcAft>
+            </a:pPr>
+            <a:r>
+              <a:rPr sz="1250" b="1" i="0">
+                <a:solidFill>
+                  <a:srgbClr val="3A66A5"/>
+                </a:solidFill>
+                <a:latin typeface="Calibri"/>
+              </a:rPr>
+              <a:t>How to read it:  </a:t>
+            </a:r>
+            <a:r>
+              <a:rPr sz="1250" b="0" i="0">
                 <a:solidFill>
                   <a:srgbClr val="555555"/>
                 </a:solidFill>
                 <a:latin typeface="Calibri"/>
               </a:rPr>
-              <a:t>Sweden 1986 · Finland 1993 · Hungary 1996 · Switzerland 1999 · Nauru 1999 · Denmark 2002 · Portugal 2004 · United Kingdom 2010 · Ireland 2012</a:t>
+              <a:t>Each panel is one country. Both lines are set to 100 at its break year: blue is carbon intensity, red is absolute CO2. The defining test is that both fall together after the break (shaded region) — intensity improved, and total emissions genuinely declined.</a:t>
             </a:r>
           </a:p>
         </p:txBody>
       </p:sp>
       <p:pic>
         <p:nvPicPr>
-          <p:cNvPr id="4" name="Picture 3" descr="image7.png"/>
+          <p:cNvPr id="5" name="Picture 4" descr="image7.png"/>
           <p:cNvPicPr>
             <a:picLocks noChangeAspect="1"/>
           </p:cNvPicPr>
@@ -6524,8 +6764,8 @@
         </p:blipFill>
         <p:spPr>
           <a:xfrm>
-            <a:off x="3068293" y="1664208"/>
-            <a:ext cx="6052365" cy="4791455"/>
+            <a:off x="3357051" y="2267712"/>
+            <a:ext cx="5474849" cy="4334256"/>
           </a:xfrm>
           <a:prstGeom prst="rect">
             <a:avLst/>
@@ -6558,8 +6798,8 @@
         </p:nvSpPr>
         <p:spPr>
           <a:xfrm>
-            <a:off x="502920" y="256032"/>
-            <a:ext cx="11201400" cy="1051560"/>
+            <a:off x="502920" y="274320"/>
+            <a:ext cx="11201400" cy="914400"/>
           </a:xfrm>
           <a:prstGeom prst="rect">
             <a:avLst/>
@@ -6580,7 +6820,7 @@
             <a:r>
               <a:rPr sz="1200" b="1" i="0">
                 <a:solidFill>
-                  <a:srgbClr val="1B7837"/>
+                  <a:srgbClr val="C77F00"/>
                 </a:solidFill>
                 <a:latin typeface="Calibri"/>
               </a:rPr>
@@ -6594,20 +6834,68 @@
               </a:spcAft>
             </a:pPr>
             <a:r>
-              <a:rPr sz="2700" b="1" i="0">
+              <a:rPr sz="2400" b="1" i="0">
                 <a:solidFill>
                   <a:srgbClr val="212121"/>
                 </a:solidFill>
                 <a:latin typeface="Calibri"/>
               </a:rPr>
               <a:t>Nineteen countries cut emissions — ten don't earn the verdict</a:t>
+            </a:r>
+          </a:p>
+        </p:txBody>
+      </p:sp>
+      <p:sp>
+        <p:nvSpPr>
+          <p:cNvPr id="3" name="TextBox 2"/>
+          <p:cNvSpPr txBox="1"/>
+          <p:nvPr/>
+        </p:nvSpPr>
+        <p:spPr>
+          <a:xfrm>
+            <a:off x="502920" y="1207008"/>
+            <a:ext cx="11201400" cy="603504"/>
+          </a:xfrm>
+          <a:prstGeom prst="rect">
+            <a:avLst/>
+          </a:prstGeom>
+          <a:noFill/>
+        </p:spPr>
+        <p:txBody>
+          <a:bodyPr wrap="square">
+            <a:spAutoFit/>
+          </a:bodyPr>
+          <a:lstStyle/>
+          <a:p>
+            <a:pPr algn="l">
+              <a:spcAft>
+                <a:spcPts val="0"/>
+              </a:spcAft>
+            </a:pPr>
+            <a:r>
+              <a:rPr sz="1250" b="1" i="0">
+                <a:solidFill>
+                  <a:srgbClr val="3A66A5"/>
+                </a:solidFill>
+                <a:latin typeface="Calibri"/>
+              </a:rPr>
+              <a:t>How to read it:  </a:t>
+            </a:r>
+            <a:r>
+              <a:rPr sz="1250" b="0" i="0">
+                <a:solidFill>
+                  <a:srgbClr val="555555"/>
+                </a:solidFill>
+                <a:latin typeface="Calibri"/>
+              </a:rPr>
+              <a:t>Each row is a country where absolute CO2 fell after a favorable bend. The whisker is the uncertainty around its break year; rows are grouped by the verdict, and each label names the best-supported mechanism. Falling emissions alone are not enough — the route matters.</a:t>
             </a:r>
           </a:p>
         </p:txBody>
       </p:sp>
       <p:pic>
         <p:nvPicPr>
-          <p:cNvPr id="3" name="Picture 2" descr="image8.png"/>
+          <p:cNvPr id="4" name="Picture 3" descr="image8.png"/>
           <p:cNvPicPr>
             <a:picLocks noChangeAspect="1"/>
           </p:cNvPicPr>
@@ -6621,8 +6909,8 @@
         </p:blipFill>
         <p:spPr>
           <a:xfrm>
-            <a:off x="2473452" y="1325880"/>
-            <a:ext cx="7242047" cy="5129783"/>
+            <a:off x="2750999" y="1865376"/>
+            <a:ext cx="6686953" cy="4736592"/>
           </a:xfrm>
           <a:prstGeom prst="rect">
             <a:avLst/>
@@ -6655,8 +6943,8 @@
         </p:nvSpPr>
         <p:spPr>
           <a:xfrm>
-            <a:off x="502920" y="256032"/>
-            <a:ext cx="11201400" cy="1051560"/>
+            <a:off x="502920" y="274320"/>
+            <a:ext cx="11201400" cy="914400"/>
           </a:xfrm>
           <a:prstGeom prst="rect">
             <a:avLst/>
@@ -6691,20 +6979,68 @@
               </a:spcAft>
             </a:pPr>
             <a:r>
-              <a:rPr sz="2700" b="1" i="0">
+              <a:rPr sz="2400" b="1" i="0">
                 <a:solidFill>
                   <a:srgbClr val="212121"/>
                 </a:solidFill>
                 <a:latin typeface="Calibri"/>
               </a:rPr>
-              <a:t>Mechanisms are regional stories; success concentrates where policy changed physical systems</a:t>
+              <a:t>Mechanisms are regional; success is concentrated</a:t>
+            </a:r>
+          </a:p>
+        </p:txBody>
+      </p:sp>
+      <p:sp>
+        <p:nvSpPr>
+          <p:cNvPr id="3" name="TextBox 2"/>
+          <p:cNvSpPr txBox="1"/>
+          <p:nvPr/>
+        </p:nvSpPr>
+        <p:spPr>
+          <a:xfrm>
+            <a:off x="502920" y="1207008"/>
+            <a:ext cx="11201400" cy="603504"/>
+          </a:xfrm>
+          <a:prstGeom prst="rect">
+            <a:avLst/>
+          </a:prstGeom>
+          <a:noFill/>
+        </p:spPr>
+        <p:txBody>
+          <a:bodyPr wrap="square">
+            <a:spAutoFit/>
+          </a:bodyPr>
+          <a:lstStyle/>
+          <a:p>
+            <a:pPr algn="l">
+              <a:spcAft>
+                <a:spcPts val="0"/>
+              </a:spcAft>
+            </a:pPr>
+            <a:r>
+              <a:rPr sz="1250" b="1" i="0">
+                <a:solidFill>
+                  <a:srgbClr val="3A66A5"/>
+                </a:solidFill>
+                <a:latin typeface="Calibri"/>
+              </a:rPr>
+              <a:t>How to read it:  </a:t>
+            </a:r>
+            <a:r>
+              <a:rPr sz="1250" b="0" i="0">
+                <a:solidFill>
+                  <a:srgbClr val="555555"/>
+                </a:solidFill>
+                <a:latin typeface="Calibri"/>
+              </a:rPr>
+              <a:t>Left map: each country is colored by the process that accompanied its break. Right map: the same countries colored by outcome verdict — dark green marks the nine constructive cases, concentrated in northern Europe.</a:t>
             </a:r>
           </a:p>
         </p:txBody>
       </p:sp>
       <p:pic>
         <p:nvPicPr>
-          <p:cNvPr id="3" name="Picture 2" descr="image9.png"/>
+          <p:cNvPr id="4" name="Picture 3" descr="image9.png"/>
           <p:cNvPicPr>
             <a:picLocks noChangeAspect="1"/>
           </p:cNvPicPr>
@@ -6718,7 +7054,7 @@
         </p:blipFill>
         <p:spPr>
           <a:xfrm>
-            <a:off x="274320" y="2552890"/>
+            <a:off x="274320" y="2781490"/>
             <a:ext cx="5806440" cy="2758059"/>
           </a:xfrm>
           <a:prstGeom prst="rect">
@@ -6728,7 +7064,7 @@
       </p:pic>
       <p:pic>
         <p:nvPicPr>
-          <p:cNvPr id="4" name="Picture 3" descr="image10.png"/>
+          <p:cNvPr id="5" name="Picture 4" descr="image10.png"/>
           <p:cNvPicPr>
             <a:picLocks noChangeAspect="1"/>
           </p:cNvPicPr>
@@ -6742,7 +7078,7 @@
         </p:blipFill>
         <p:spPr>
           <a:xfrm>
-            <a:off x="6172200" y="2552890"/>
+            <a:off x="6172200" y="2781490"/>
             <a:ext cx="5806440" cy="2758059"/>
           </a:xfrm>
           <a:prstGeom prst="rect">
@@ -6776,8 +7112,8 @@
         </p:nvSpPr>
         <p:spPr>
           <a:xfrm>
-            <a:off x="502920" y="256032"/>
-            <a:ext cx="11201400" cy="1051560"/>
+            <a:off x="502920" y="274320"/>
+            <a:ext cx="11201400" cy="914400"/>
           </a:xfrm>
           <a:prstGeom prst="rect">
             <a:avLst/>
@@ -6798,7 +7134,7 @@
             <a:r>
               <a:rPr sz="1200" b="1" i="0">
                 <a:solidFill>
-                  <a:srgbClr val="1B7837"/>
+                  <a:srgbClr val="B33A3A"/>
                 </a:solidFill>
                 <a:latin typeface="Calibri"/>
               </a:rPr>
@@ -6812,20 +7148,68 @@
               </a:spcAft>
             </a:pPr>
             <a:r>
-              <a:rPr sz="2700" b="1" i="0">
+              <a:rPr sz="2400" b="1" i="0">
                 <a:solidFill>
                   <a:srgbClr val="212121"/>
                 </a:solidFill>
                 <a:latin typeface="Calibri"/>
               </a:rPr>
-              <a:t>Independent raters recognize the same countries — on thin coverage</a:t>
+              <a:t>Independent raters recognize the same countries</a:t>
+            </a:r>
+          </a:p>
+        </p:txBody>
+      </p:sp>
+      <p:sp>
+        <p:nvSpPr>
+          <p:cNvPr id="3" name="TextBox 2"/>
+          <p:cNvSpPr txBox="1"/>
+          <p:nvPr/>
+        </p:nvSpPr>
+        <p:spPr>
+          <a:xfrm>
+            <a:off x="502920" y="1207008"/>
+            <a:ext cx="11201400" cy="603504"/>
+          </a:xfrm>
+          <a:prstGeom prst="rect">
+            <a:avLst/>
+          </a:prstGeom>
+          <a:noFill/>
+        </p:spPr>
+        <p:txBody>
+          <a:bodyPr wrap="square">
+            <a:spAutoFit/>
+          </a:bodyPr>
+          <a:lstStyle/>
+          <a:p>
+            <a:pPr algn="l">
+              <a:spcAft>
+                <a:spcPts val="0"/>
+              </a:spcAft>
+            </a:pPr>
+            <a:r>
+              <a:rPr sz="1250" b="1" i="0">
+                <a:solidFill>
+                  <a:srgbClr val="3A66A5"/>
+                </a:solidFill>
+                <a:latin typeface="Calibri"/>
+              </a:rPr>
+              <a:t>How to read it:  </a:t>
+            </a:r>
+            <a:r>
+              <a:rPr sz="1250" b="0" i="0">
+                <a:solidFill>
+                  <a:srgbClr val="555555"/>
+                </a:solidFill>
+                <a:latin typeface="Calibri"/>
+              </a:rPr>
+              <a:t>Each dot is a country covered by the rating, placed by where it ranks among covered countries (right = rated better). Green triangles are our policy-enabled cases; the vertical bars mark each group's median. The policy cases rank high on both ratings — but only 3 and 2 of them are covered, so we show every point rather than hide the small sample.</a:t>
             </a:r>
           </a:p>
         </p:txBody>
       </p:sp>
       <p:pic>
         <p:nvPicPr>
-          <p:cNvPr id="3" name="Picture 2" descr="takeaway_fig06_external_corroboration.png"/>
+          <p:cNvPr id="4" name="Picture 3" descr="takeaway_fig06_external_corroboration.png"/>
           <p:cNvPicPr>
             <a:picLocks noChangeAspect="1"/>
           </p:cNvPicPr>
@@ -6839,8 +7223,8 @@
         </p:blipFill>
         <p:spPr>
           <a:xfrm>
-            <a:off x="598278" y="1325880"/>
-            <a:ext cx="10992394" cy="5129783"/>
+            <a:off x="1019556" y="1865376"/>
+            <a:ext cx="10149840" cy="4736592"/>
           </a:xfrm>
           <a:prstGeom prst="rect">
             <a:avLst/>
@@ -6873,8 +7257,8 @@
         </p:nvSpPr>
         <p:spPr>
           <a:xfrm>
-            <a:off x="502920" y="256032"/>
-            <a:ext cx="11201400" cy="1051560"/>
+            <a:off x="502920" y="274320"/>
+            <a:ext cx="11201400" cy="914400"/>
           </a:xfrm>
           <a:prstGeom prst="rect">
             <a:avLst/>
@@ -6909,7 +7293,7 @@
               </a:spcAft>
             </a:pPr>
             <a:r>
-              <a:rPr sz="2700" b="1" i="0">
+              <a:rPr sz="2400" b="1" i="0">
                 <a:solidFill>
                   <a:srgbClr val="212121"/>
                 </a:solidFill>
@@ -7034,7 +7418,7 @@
                 </a:solidFill>
                 <a:latin typeface="Calibri"/>
               </a:rPr>
-              <a:t>Rather than assuming treaty years are turning points, we estimate structural breaks from the data — globally and for every country with adequate annual series — then use historical evidence to ask why the trend changed.</a:t>
+              <a:t>Rather than assuming treaty years are turning points, we let the data tell us when trends actually changed — globally and for every country with enough annual data — and then use historical evidence to ask why.</a:t>
             </a:r>
           </a:p>
         </p:txBody>
@@ -7079,81 +7463,65 @@
           <a:p>
             <a:pPr algn="l">
               <a:spcAft>
+                <a:spcPts val="400"/>
+              </a:spcAft>
+            </a:pPr>
+            <a:r>
+              <a:rPr sz="1400" b="0" i="0">
+                <a:solidFill>
+                  <a:srgbClr val="555555"/>
+                </a:solidFill>
+                <a:latin typeface="Calibri"/>
+              </a:rPr>
+              <a:t>Emissions can be split into three moving parts:</a:t>
+            </a:r>
+          </a:p>
+          <a:p>
+            <a:pPr algn="l">
+              <a:spcAft>
+                <a:spcPts val="1000"/>
+              </a:spcAft>
+            </a:pPr>
+            <a:r>
+              <a:rPr sz="1400" b="1" i="0">
+                <a:solidFill>
+                  <a:srgbClr val="212121"/>
+                </a:solidFill>
+                <a:latin typeface="Calibri"/>
+              </a:rPr>
+              <a:t>CO2 growth = economic growth + change in fuel mix + change in energy efficiency</a:t>
+            </a:r>
+          </a:p>
+          <a:p>
+            <a:pPr algn="l">
+              <a:spcAft>
+                <a:spcPts val="800"/>
+              </a:spcAft>
+            </a:pPr>
+            <a:r>
+              <a:rPr sz="1400" b="0" i="0">
+                <a:solidFill>
+                  <a:srgbClr val="555555"/>
+                </a:solidFill>
+                <a:latin typeface="Calibri"/>
+              </a:rPr>
+              <a:t>Emissions cannot bend until the fuel mix or efficiency improves faster. Intensity is the leading indicator: any policy effect must show up there first — before it can ever show up in emissions.</a:t>
+            </a:r>
+          </a:p>
+          <a:p>
+            <a:pPr algn="l">
+              <a:spcAft>
                 <a:spcPts val="0"/>
               </a:spcAft>
             </a:pPr>
             <a:r>
-              <a:rPr sz="1400" b="0" i="0">
+              <a:rPr sz="1400" b="1" i="0">
                 <a:solidFill>
                   <a:srgbClr val="212121"/>
                 </a:solidFill>
-                <a:latin typeface="Consolas"/>
-              </a:rPr>
-              <a:t>growth of CO2  =  growth of GDP</a:t>
-            </a:r>
-          </a:p>
-          <a:p>
-            <a:pPr algn="l">
-              <a:spcAft>
-                <a:spcPts val="0"/>
-              </a:spcAft>
-            </a:pPr>
-            <a:r>
-              <a:rPr sz="1400" b="0" i="0">
-                <a:solidFill>
-                  <a:srgbClr val="212121"/>
-                </a:solidFill>
-                <a:latin typeface="Consolas"/>
-              </a:rPr>
-              <a:t>  +  change in C/E  (fuel mix)</a:t>
-            </a:r>
-          </a:p>
-          <a:p>
-            <a:pPr algn="l">
-              <a:spcAft>
-                <a:spcPts val="1000"/>
-              </a:spcAft>
-            </a:pPr>
-            <a:r>
-              <a:rPr sz="1400" b="0" i="0">
-                <a:solidFill>
-                  <a:srgbClr val="212121"/>
-                </a:solidFill>
-                <a:latin typeface="Consolas"/>
-              </a:rPr>
-              <a:t>  +  change in E/GDP  (efficiency)</a:t>
-            </a:r>
-          </a:p>
-          <a:p>
-            <a:pPr algn="l">
-              <a:spcAft>
-                <a:spcPts val="800"/>
-              </a:spcAft>
-            </a:pPr>
-            <a:r>
-              <a:rPr sz="1400" b="0" i="0">
-                <a:solidFill>
-                  <a:srgbClr val="555555"/>
-                </a:solidFill>
-                <a:latin typeface="Calibri"/>
-              </a:rPr>
-              <a:t>Emissions cannot bend until an intensity slope accelerates. Intensity is the leading indicator: any policy signal must appear there first — on carbon or energy intensity, not necessarily on emissions.</a:t>
-            </a:r>
-          </a:p>
-          <a:p>
-            <a:pPr algn="l">
-              <a:spcAft>
-                <a:spcPts val="0"/>
-              </a:spcAft>
-            </a:pPr>
-            <a:r>
-              <a:rPr sz="1400" b="1" i="0">
-                <a:solidFill>
-                  <a:srgbClr val="212121"/>
-                </a:solidFill>
-                <a:latin typeface="Calibri"/>
-              </a:rPr>
-              <a:t>Unless the intensity terms outpace GDP growth, emissions cannot stabilize.</a:t>
+                <a:latin typeface="Calibri"/>
+              </a:rPr>
+              <a:t>Unless intensity improves faster than the economy grows, emissions cannot stabilize.</a:t>
             </a:r>
           </a:p>
         </p:txBody>
@@ -7184,8 +7552,8 @@
         </p:nvSpPr>
         <p:spPr>
           <a:xfrm>
-            <a:off x="502920" y="256032"/>
-            <a:ext cx="11201400" cy="1051560"/>
+            <a:off x="502920" y="274320"/>
+            <a:ext cx="11201400" cy="914400"/>
           </a:xfrm>
           <a:prstGeom prst="rect">
             <a:avLst/>
@@ -7220,7 +7588,7 @@
               </a:spcAft>
             </a:pPr>
             <a:r>
-              <a:rPr sz="2700" b="1" i="0">
+              <a:rPr sz="2400" b="1" i="0">
                 <a:solidFill>
                   <a:srgbClr val="212121"/>
                 </a:solidFill>
@@ -7281,7 +7649,7 @@
                 </a:solidFill>
                 <a:latin typeface="Calibri"/>
               </a:rPr>
-              <a:t>Of 17 countries eligible under both accountings, only 6 agree within 5 years; the median gap is ~12 years. Some 'domestic' transitions partly reflect trade and offshoring — a main result, not a footnote. (Consumption series begin in 1990, so very early production breaks cannot be matched by construction.)</a:t>
+              <a:t>When emissions embodied in trade are assigned to consumers instead of producers, only 6 of 17 comparable countries keep a break within 5 years of their production-based date; the median shift is ~12 years. Some 'domestic' transitions partly reflect offshoring — a main result, not a footnote.</a:t>
             </a:r>
           </a:p>
         </p:txBody>
@@ -7336,7 +7704,7 @@
                 </a:solidFill>
                 <a:latin typeface="Calibri"/>
               </a:rPr>
-              <a:t>Pricing is negatively associated with C/E in country-and-year fixed-effects models (contemporaneous strongest); C/GDP and E/GDP estimates are imprecise. OECD EPS covers only 15 of 28 focal countries. Associational, not causal.</a:t>
+              <a:t>Carbon pricing is associated with a cleaner fuel mix in panel models with country and year controls; effects on the other components are imprecise. Policy-stringency data cover only 15 of 28 focal countries. Associational, not causal.</a:t>
             </a:r>
           </a:p>
         </p:txBody>
@@ -7391,7 +7759,7 @@
                 </a:solidFill>
                 <a:latin typeface="Calibri"/>
               </a:rPr>
-              <a:t>45% of documented events within 2 years of the break vs ~17% by chance; 80% within 5 vs 37%; 70% inside the episode vs 33% — far beyond retrospective storytelling.</a:t>
+              <a:t>45% of documented events fall within 2 years of the estimated break versus ~17% if dates were drawn at random; 80% vs 37% within 5 years; 70% vs 33% inside the episode. The historical classifications carry real temporal information — far beyond retrospective storytelling.</a:t>
             </a:r>
           </a:p>
         </p:txBody>
@@ -7446,7 +7814,7 @@
                 </a:solidFill>
                 <a:latin typeface="Calibri"/>
               </a:rPr>
-              <a:t>Break timing identifies change, not cause. Attribution and outcome classification each leave 22 cases open — restraint that makes the resolved 75% credible. No counterfactual: a treaty that prevents backsliding produces no break at all.</a:t>
+              <a:t>Break timing identifies change, not cause. Attribution and outcome classification each leave 22 cases open — restraint that makes the resolved 75% credible. And there is no counterfactual: a treaty that prevents backsliding produces no break at all.</a:t>
             </a:r>
           </a:p>
         </p:txBody>
@@ -7477,8 +7845,8 @@
         </p:nvSpPr>
         <p:spPr>
           <a:xfrm>
-            <a:off x="502920" y="256032"/>
-            <a:ext cx="11201400" cy="1051560"/>
+            <a:off x="502920" y="274320"/>
+            <a:ext cx="11201400" cy="914400"/>
           </a:xfrm>
           <a:prstGeom prst="rect">
             <a:avLst/>
@@ -7513,20 +7881,68 @@
               </a:spcAft>
             </a:pPr>
             <a:r>
-              <a:rPr sz="2700" b="1" i="0">
+              <a:rPr sz="2400" b="1" i="0">
                 <a:solidFill>
                   <a:srgbClr val="212121"/>
                 </a:solidFill>
                 <a:latin typeface="Calibri"/>
               </a:rPr>
               <a:t>Curves bend everywhere; decarbonization is rare</a:t>
+            </a:r>
+          </a:p>
+        </p:txBody>
+      </p:sp>
+      <p:sp>
+        <p:nvSpPr>
+          <p:cNvPr id="3" name="TextBox 2"/>
+          <p:cNvSpPr txBox="1"/>
+          <p:nvPr/>
+        </p:nvSpPr>
+        <p:spPr>
+          <a:xfrm>
+            <a:off x="502920" y="1207008"/>
+            <a:ext cx="11201400" cy="603504"/>
+          </a:xfrm>
+          <a:prstGeom prst="rect">
+            <a:avLst/>
+          </a:prstGeom>
+          <a:noFill/>
+        </p:spPr>
+        <p:txBody>
+          <a:bodyPr wrap="square">
+            <a:spAutoFit/>
+          </a:bodyPr>
+          <a:lstStyle/>
+          <a:p>
+            <a:pPr algn="l">
+              <a:spcAft>
+                <a:spcPts val="0"/>
+              </a:spcAft>
+            </a:pPr>
+            <a:r>
+              <a:rPr sz="1250" b="1" i="0">
+                <a:solidFill>
+                  <a:srgbClr val="3A66A5"/>
+                </a:solidFill>
+                <a:latin typeface="Calibri"/>
+              </a:rPr>
+              <a:t>How to read it:  </a:t>
+            </a:r>
+            <a:r>
+              <a:rPr sz="1250" b="0" i="0">
+                <a:solidFill>
+                  <a:srgbClr val="555555"/>
+                </a:solidFill>
+                <a:latin typeface="Calibri"/>
+              </a:rPr>
+              <a:t>All 97 breaks looked statistically favorable. The colors show what they turned out to be once persistence, mechanism, and absolute emissions are checked — only the dark green block on the right is unambiguous decarbonization.</a:t>
             </a:r>
           </a:p>
         </p:txBody>
       </p:sp>
       <p:pic>
         <p:nvPicPr>
-          <p:cNvPr id="3" name="Picture 2" descr="image12.png"/>
+          <p:cNvPr id="4" name="Picture 3" descr="image12.png"/>
           <p:cNvPicPr>
             <a:picLocks noChangeAspect="1"/>
           </p:cNvPicPr>
@@ -7540,7 +7956,7 @@
         </p:blipFill>
         <p:spPr>
           <a:xfrm>
-            <a:off x="320040" y="1950182"/>
+            <a:off x="320040" y="2293082"/>
             <a:ext cx="11548872" cy="3881178"/>
           </a:xfrm>
           <a:prstGeom prst="rect">
@@ -7575,7 +7991,7 @@
         <p:spPr>
           <a:xfrm>
             <a:off x="822960" y="1051560"/>
-            <a:ext cx="10515600" cy="1645920"/>
+            <a:ext cx="10515600" cy="1737360"/>
           </a:xfrm>
           <a:prstGeom prst="rect">
             <a:avLst/>
@@ -7650,7 +8066,7 @@
               </a:spcAft>
             </a:pPr>
             <a:r>
-              <a:rPr sz="1400" b="1">
+              <a:rPr sz="1400" b="1" i="0">
                 <a:solidFill>
                   <a:srgbClr val="1B7837"/>
                 </a:solidFill>
@@ -7659,7 +8075,7 @@
               <a:t>—  </a:t>
             </a:r>
             <a:r>
-              <a:rPr sz="1400" b="0">
+              <a:rPr sz="1400" b="0" i="0">
                 <a:solidFill>
                   <a:srgbClr val="555555"/>
                 </a:solidFill>
@@ -7675,7 +8091,7 @@
               </a:spcAft>
             </a:pPr>
             <a:r>
-              <a:rPr sz="1400" b="1">
+              <a:rPr sz="1400" b="1" i="0">
                 <a:solidFill>
                   <a:srgbClr val="1B7837"/>
                 </a:solidFill>
@@ -7684,7 +8100,7 @@
               <a:t>—  </a:t>
             </a:r>
             <a:r>
-              <a:rPr sz="1400" b="0">
+              <a:rPr sz="1400" b="0" i="0">
                 <a:solidFill>
                   <a:srgbClr val="555555"/>
                 </a:solidFill>
@@ -7700,7 +8116,7 @@
               </a:spcAft>
             </a:pPr>
             <a:r>
-              <a:rPr sz="1400" b="1">
+              <a:rPr sz="1400" b="1" i="0">
                 <a:solidFill>
                   <a:srgbClr val="1B7837"/>
                 </a:solidFill>
@@ -7709,7 +8125,7 @@
               <a:t>—  </a:t>
             </a:r>
             <a:r>
-              <a:rPr sz="1400" b="0">
+              <a:rPr sz="1400" b="0" i="0">
                 <a:solidFill>
                   <a:srgbClr val="555555"/>
                 </a:solidFill>
@@ -7725,7 +8141,7 @@
               </a:spcAft>
             </a:pPr>
             <a:r>
-              <a:rPr sz="1400" b="1">
+              <a:rPr sz="1400" b="1" i="0">
                 <a:solidFill>
                   <a:srgbClr val="1B7837"/>
                 </a:solidFill>
@@ -7734,7 +8150,7 @@
               <a:t>—  </a:t>
             </a:r>
             <a:r>
-              <a:rPr sz="1400" b="0">
+              <a:rPr sz="1400" b="0" i="0">
                 <a:solidFill>
                   <a:srgbClr val="555555"/>
                 </a:solidFill>
@@ -7810,8 +8226,8 @@
         </p:nvSpPr>
         <p:spPr>
           <a:xfrm>
-            <a:off x="502920" y="256032"/>
-            <a:ext cx="11201400" cy="1051560"/>
+            <a:off x="502920" y="274320"/>
+            <a:ext cx="11201400" cy="914400"/>
           </a:xfrm>
           <a:prstGeom prst="rect">
             <a:avLst/>
@@ -7836,7 +8252,7 @@
                 </a:solidFill>
                 <a:latin typeface="Calibri"/>
               </a:rPr>
-              <a:t>METHODS</a:t>
+              <a:t>HOW WE MEASURE IT</a:t>
             </a:r>
           </a:p>
           <a:p>
@@ -7846,13 +8262,13 @@
               </a:spcAft>
             </a:pPr>
             <a:r>
-              <a:rPr sz="2700" b="1" i="0">
+              <a:rPr sz="2400" b="1" i="0">
                 <a:solidFill>
                   <a:srgbClr val="212121"/>
                 </a:solidFill>
                 <a:latin typeface="Calibri"/>
               </a:rPr>
-              <a:t>What a breakpoint means — and the Kaya lens</a:t>
+              <a:t>Finding the bend: two straight lines and a kink</a:t>
             </a:r>
           </a:p>
         </p:txBody>
@@ -7865,8 +8281,8 @@
         </p:nvSpPr>
         <p:spPr>
           <a:xfrm>
-            <a:off x="502920" y="1463040"/>
-            <a:ext cx="5577840" cy="4937760"/>
+            <a:off x="502920" y="1417320"/>
+            <a:ext cx="5577840" cy="5029200"/>
           </a:xfrm>
           <a:prstGeom prst="rect">
             <a:avLst/>
@@ -7881,65 +8297,108 @@
           <a:p>
             <a:pPr algn="l">
               <a:spcAft>
-                <a:spcPts val="600"/>
-              </a:spcAft>
-            </a:pPr>
-            <a:r>
-              <a:rPr sz="1600" b="1" i="0">
+                <a:spcPts val="800"/>
+              </a:spcAft>
+            </a:pPr>
+            <a:r>
+              <a:rPr sz="1550" b="1" i="0">
                 <a:solidFill>
                   <a:srgbClr val="212121"/>
                 </a:solidFill>
                 <a:latin typeface="Calibri"/>
               </a:rPr>
-              <a:t>The breakpoint model</a:t>
-            </a:r>
-          </a:p>
-          <a:p>
-            <a:pPr algn="l">
-              <a:spcAft>
-                <a:spcPts val="600"/>
-              </a:spcAft>
-            </a:pPr>
-            <a:r>
-              <a:rPr sz="1400" b="0" i="0">
+              <a:t>Three steps, no assumptions about treaty years</a:t>
+            </a:r>
+          </a:p>
+          <a:p>
+            <a:pPr algn="l">
+              <a:spcAft>
+                <a:spcPts val="800"/>
+              </a:spcAft>
+            </a:pPr>
+            <a:r>
+              <a:rPr sz="1350" b="1" i="0">
+                <a:solidFill>
+                  <a:srgbClr val="3A66A5"/>
+                </a:solidFill>
+                <a:latin typeface="Calibri"/>
+              </a:rPr>
+              <a:t>1.  </a:t>
+            </a:r>
+            <a:r>
+              <a:rPr sz="1350" b="0" i="0">
+                <a:solidFill>
+                  <a:srgbClr val="555555"/>
+                </a:solidFill>
+                <a:latin typeface="Calibri"/>
+              </a:rPr>
+              <a:t>Plot each series on a log scale, so a straight line means a steady percentage change per year.</a:t>
+            </a:r>
+          </a:p>
+          <a:p>
+            <a:pPr algn="l">
+              <a:spcAft>
+                <a:spcPts val="800"/>
+              </a:spcAft>
+            </a:pPr>
+            <a:r>
+              <a:rPr sz="1350" b="1" i="0">
+                <a:solidFill>
+                  <a:srgbClr val="3A66A5"/>
+                </a:solidFill>
+                <a:latin typeface="Calibri"/>
+              </a:rPr>
+              <a:t>2.  </a:t>
+            </a:r>
+            <a:r>
+              <a:rPr sz="1350" b="0" i="0">
+                <a:solidFill>
+                  <a:srgbClr val="555555"/>
+                </a:solidFill>
+                <a:latin typeface="Calibri"/>
+              </a:rPr>
+              <a:t>Fit two straight lines that meet at a kink — the 'breakpoint'. Try every possible kink year and keep the one that fits the data best. That year is the estimate of when the trend changed.</a:t>
+            </a:r>
+          </a:p>
+          <a:p>
+            <a:pPr algn="l">
+              <a:spcAft>
+                <a:spcPts val="1200"/>
+              </a:spcAft>
+            </a:pPr>
+            <a:r>
+              <a:rPr sz="1350" b="1" i="0">
+                <a:solidFill>
+                  <a:srgbClr val="3A66A5"/>
+                </a:solidFill>
+                <a:latin typeface="Calibri"/>
+              </a:rPr>
+              <a:t>3.  </a:t>
+            </a:r>
+            <a:r>
+              <a:rPr sz="1350" b="0" i="0">
+                <a:solidFill>
+                  <a:srgbClr val="555555"/>
+                </a:solidFill>
+                <a:latin typeface="Calibri"/>
+              </a:rPr>
+              <a:t>Stress-test the date: re-estimate it on many statistically reshuffled versions of the series. If the estimated year barely moves, the break is credible; if it jumps around, we say so.</a:t>
+            </a:r>
+          </a:p>
+          <a:p>
+            <a:pPr algn="l">
+              <a:spcAft>
+                <a:spcPts val="800"/>
+              </a:spcAft>
+            </a:pPr>
+            <a:r>
+              <a:rPr sz="1350" b="1" i="0">
                 <a:solidFill>
                   <a:srgbClr val="212121"/>
                 </a:solidFill>
-                <a:latin typeface="Consolas"/>
-              </a:rPr>
-              <a:t>y(t) = a + b·t + d·max(t − k, 0) + e(t)</a:t>
-            </a:r>
-          </a:p>
-          <a:p>
-            <a:pPr algn="l">
-              <a:spcAft>
-                <a:spcPts val="1000"/>
-              </a:spcAft>
-            </a:pPr>
-            <a:r>
-              <a:rPr sz="1350" b="0" i="0">
-                <a:solidFill>
-                  <a:srgbClr val="555555"/>
-                </a:solidFill>
-                <a:latin typeface="Calibri"/>
-              </a:rPr>
-              <a:t>b is the pre-break slope; b + d the post-break slope; d the change. The unrestricted model searches all admissible years for the strongest slope change; a moving-block bootstrap describes how stable that date is under serially dependent noise.</a:t>
-            </a:r>
-          </a:p>
-          <a:p>
-            <a:pPr algn="l">
-              <a:spcAft>
-                <a:spcPts val="1000"/>
-              </a:spcAft>
-            </a:pPr>
-            <a:r>
-              <a:rPr sz="1350" b="0" i="0">
-                <a:solidFill>
-                  <a:srgbClr val="212121"/>
-                </a:solidFill>
-                <a:latin typeface="Calibri"/>
-              </a:rPr>
-              <a:t>A breakpoint identifies when a trend changed — with uncertainty. It is not a peak year, not a policy-adoption date, and never a causal estimate by itself. Historical and external evidence answers why.</a:t>
+                <a:latin typeface="Calibri"/>
+              </a:rPr>
+              <a:t>A breakpoint tells us when a trend changed — never, by itself, why. Historical evidence answers that separately.</a:t>
             </a:r>
           </a:p>
           <a:p>
@@ -7949,13 +8408,13 @@
               </a:spcAft>
             </a:pPr>
             <a:r>
-              <a:rPr sz="1350" b="0" i="0">
-                <a:solidFill>
-                  <a:srgbClr val="555555"/>
-                </a:solidFill>
-                <a:latin typeface="Calibri"/>
-              </a:rPr>
-              <a:t>Inference: Newey–West standard errors for fixed-date tests; BIC for model evidence; moving-block bootstrap for date stability.</a:t>
+              <a:rPr sz="1050" b="0" i="1">
+                <a:solidFill>
+                  <a:srgbClr val="8A8A8A"/>
+                </a:solidFill>
+                <a:latin typeface="Calibri"/>
+              </a:rPr>
+              <a:t>(Formally: y(t) = a + b·t + d·max(t−k, 0); slope b before year k, b+d after. Uncertainty via moving-block bootstrap; autocorrelation-robust standard errors for fixed-date tests.)</a:t>
             </a:r>
           </a:p>
         </p:txBody>
@@ -7968,8 +8427,8 @@
         </p:nvSpPr>
         <p:spPr>
           <a:xfrm>
-            <a:off x="6400800" y="1463040"/>
-            <a:ext cx="5303520" cy="4937760"/>
+            <a:off x="6400800" y="1417320"/>
+            <a:ext cx="5303520" cy="5029200"/>
           </a:xfrm>
           <a:prstGeom prst="rect">
             <a:avLst/>
@@ -7984,17 +8443,17 @@
           <a:p>
             <a:pPr algn="l">
               <a:spcAft>
-                <a:spcPts val="600"/>
-              </a:spcAft>
-            </a:pPr>
-            <a:r>
-              <a:rPr sz="1600" b="1" i="0">
+                <a:spcPts val="800"/>
+              </a:spcAft>
+            </a:pPr>
+            <a:r>
+              <a:rPr sz="1550" b="1" i="0">
                 <a:solidFill>
                   <a:srgbClr val="212121"/>
                 </a:solidFill>
                 <a:latin typeface="Calibri"/>
               </a:rPr>
-              <a:t>The Kaya decomposition</a:t>
+              <a:t>Two doors for any improvement</a:t>
             </a:r>
           </a:p>
           <a:p>
@@ -8004,104 +8463,79 @@
               </a:spcAft>
             </a:pPr>
             <a:r>
-              <a:rPr sz="1500" b="0" i="0">
+              <a:rPr sz="1350" b="0" i="0">
+                <a:solidFill>
+                  <a:srgbClr val="555555"/>
+                </a:solidFill>
+                <a:latin typeface="Calibri"/>
+              </a:rPr>
+              <a:t>Carbon intensity — CO2 per dollar of output — can only improve through one of two doors:</a:t>
+            </a:r>
+          </a:p>
+          <a:p>
+            <a:pPr algn="l">
+              <a:spcAft>
+                <a:spcPts val="800"/>
+              </a:spcAft>
+            </a:pPr>
+            <a:r>
+              <a:rPr sz="1350" b="1" i="0">
+                <a:solidFill>
+                  <a:srgbClr val="1B7837"/>
+                </a:solidFill>
+                <a:latin typeface="Calibri"/>
+              </a:rPr>
+              <a:t>Cleaner energy (C/E):  </a:t>
+            </a:r>
+            <a:r>
+              <a:rPr sz="1350" b="0" i="0">
+                <a:solidFill>
+                  <a:srgbClr val="555555"/>
+                </a:solidFill>
+                <a:latin typeface="Calibri"/>
+              </a:rPr>
+              <a:t>less CO2 per unit of energy — fuel switching, nuclear, renewables, the power system.</a:t>
+            </a:r>
+          </a:p>
+          <a:p>
+            <a:pPr algn="l">
+              <a:spcAft>
+                <a:spcPts val="1000"/>
+              </a:spcAft>
+            </a:pPr>
+            <a:r>
+              <a:rPr sz="1350" b="1" i="0">
+                <a:solidFill>
+                  <a:srgbClr val="C77F00"/>
+                </a:solidFill>
+                <a:latin typeface="Calibri"/>
+              </a:rPr>
+              <a:t>Less energy per dollar (E/GDP):  </a:t>
+            </a:r>
+            <a:r>
+              <a:rPr sz="1350" b="0" i="0">
+                <a:solidFill>
+                  <a:srgbClr val="555555"/>
+                </a:solidFill>
+                <a:latin typeface="Calibri"/>
+              </a:rPr>
+              <a:t>efficiency, and changes in what the economy makes — industry versus services.</a:t>
+            </a:r>
+          </a:p>
+          <a:p>
+            <a:pPr algn="l">
+              <a:spcAft>
+                <a:spcPts val="0"/>
+              </a:spcAft>
+            </a:pPr>
+            <a:r>
+              <a:rPr sz="1350" b="0" i="0">
                 <a:solidFill>
                   <a:srgbClr val="212121"/>
                 </a:solidFill>
-                <a:latin typeface="Consolas"/>
-              </a:rPr>
-              <a:t>C/GDP = (C/E) × (E/GDP)</a:t>
-            </a:r>
-          </a:p>
-          <a:p>
-            <a:pPr algn="l">
-              <a:spcAft>
-                <a:spcPts val="600"/>
-              </a:spcAft>
-            </a:pPr>
-            <a:r>
-              <a:rPr sz="1350" b="1">
-                <a:solidFill>
-                  <a:srgbClr val="3A66A5"/>
-                </a:solidFill>
-                <a:latin typeface="Calibri"/>
-              </a:rPr>
-              <a:t>C/GDP — </a:t>
-            </a:r>
-            <a:r>
-              <a:rPr sz="1350" b="0">
-                <a:solidFill>
-                  <a:srgbClr val="555555"/>
-                </a:solidFill>
-                <a:latin typeface="Calibri"/>
-              </a:rPr>
-              <a:t>aggregate carbon intensity of output: the observed outcome.</a:t>
-            </a:r>
-          </a:p>
-          <a:p>
-            <a:pPr algn="l">
-              <a:spcAft>
-                <a:spcPts val="600"/>
-              </a:spcAft>
-            </a:pPr>
-            <a:r>
-              <a:rPr sz="1350" b="1">
-                <a:solidFill>
-                  <a:srgbClr val="1B7837"/>
-                </a:solidFill>
-                <a:latin typeface="Calibri"/>
-              </a:rPr>
-              <a:t>C/E — </a:t>
-            </a:r>
-            <a:r>
-              <a:rPr sz="1350" b="0">
-                <a:solidFill>
-                  <a:srgbClr val="555555"/>
-                </a:solidFill>
-                <a:latin typeface="Calibri"/>
-              </a:rPr>
-              <a:t>supply side: fuel mix, electricity systems, conversion technology.</a:t>
-            </a:r>
-          </a:p>
-          <a:p>
-            <a:pPr algn="l">
-              <a:spcAft>
-                <a:spcPts val="1000"/>
-              </a:spcAft>
-            </a:pPr>
-            <a:r>
-              <a:rPr sz="1350" b="1">
-                <a:solidFill>
-                  <a:srgbClr val="C77F00"/>
-                </a:solidFill>
-                <a:latin typeface="Calibri"/>
-              </a:rPr>
-              <a:t>E/GDP — </a:t>
-            </a:r>
-            <a:r>
-              <a:rPr sz="1350" b="0">
-                <a:solidFill>
-                  <a:srgbClr val="555555"/>
-                </a:solidFill>
-                <a:latin typeface="Calibri"/>
-              </a:rPr>
-              <a:t>demand side: efficiency, sectoral structure, economic composition.</a:t>
-            </a:r>
-          </a:p>
-          <a:p>
-            <a:pPr algn="l">
-              <a:spcAft>
-                <a:spcPts val="0"/>
-              </a:spcAft>
-            </a:pPr>
-            <a:r>
-              <a:rPr sz="1350" b="0" i="0">
-                <a:solidFill>
-                  <a:srgbClr val="212121"/>
-                </a:solidFill>
-                <a:latin typeface="Calibri"/>
-              </a:rPr>
-              <a:t>We estimate all three, for the world aggregate and every country, with one harmonized procedure. The component pattern constrains which mechanisms are plausible.</a:t>
+                <a:latin typeface="Calibri"/>
+              </a:rPr>
+              <a:t>We estimate the bend in the overall series and in both doors, for the world and for every country, with one identical procedure. Which door moved tells us what kind of transition happened — a fuel-mix bend points to energy policy or markets; an efficiency bend often points to economic change.</a:t>
             </a:r>
           </a:p>
         </p:txBody>
@@ -8132,8 +8566,8 @@
         </p:nvSpPr>
         <p:spPr>
           <a:xfrm>
-            <a:off x="502920" y="256032"/>
-            <a:ext cx="11201400" cy="1051560"/>
+            <a:off x="502920" y="274320"/>
+            <a:ext cx="11201400" cy="914400"/>
           </a:xfrm>
           <a:prstGeom prst="rect">
             <a:avLst/>
@@ -8158,7 +8592,7 @@
                 </a:solidFill>
                 <a:latin typeface="Calibri"/>
               </a:rPr>
-              <a:t>METHODS</a:t>
+              <a:t>HOW WE MEASURE IT</a:t>
             </a:r>
           </a:p>
           <a:p>
@@ -8168,13 +8602,13 @@
               </a:spcAft>
             </a:pPr>
             <a:r>
-              <a:rPr sz="2700" b="1" i="0">
+              <a:rPr sz="2400" b="1" i="0">
                 <a:solidFill>
                   <a:srgbClr val="212121"/>
                 </a:solidFill>
                 <a:latin typeface="Calibri"/>
               </a:rPr>
-              <a:t>From 204 jurisdictions to 97 eligible national breaks</a:t>
+              <a:t>Which breaks do we trust — and when does a treaty get credit?</a:t>
             </a:r>
           </a:p>
         </p:txBody>
@@ -8187,8 +8621,8 @@
         </p:nvSpPr>
         <p:spPr>
           <a:xfrm>
-            <a:off x="502920" y="1371600"/>
-            <a:ext cx="4937760" cy="5120640"/>
+            <a:off x="502920" y="1417320"/>
+            <a:ext cx="5029200" cy="5029200"/>
           </a:xfrm>
           <a:prstGeom prst="rect">
             <a:avLst/>
@@ -8203,27 +8637,27 @@
           <a:p>
             <a:pPr algn="l">
               <a:spcAft>
-                <a:spcPts val="600"/>
-              </a:spcAft>
-            </a:pPr>
-            <a:r>
-              <a:rPr sz="1600" b="1" i="0">
+                <a:spcPts val="800"/>
+              </a:spcAft>
+            </a:pPr>
+            <a:r>
+              <a:rPr sz="1550" b="1" i="0">
                 <a:solidFill>
                   <a:srgbClr val="212121"/>
                 </a:solidFill>
                 <a:latin typeface="Calibri"/>
               </a:rPr>
-              <a:t>Eligibility is strict by design</a:t>
-            </a:r>
-          </a:p>
-          <a:p>
-            <a:pPr algn="l">
-              <a:spcAft>
-                <a:spcPts val="500"/>
-              </a:spcAft>
-            </a:pPr>
-            <a:r>
-              <a:rPr sz="1300" b="1">
+              <a:t>A country's break counts only if:</a:t>
+            </a:r>
+          </a:p>
+          <a:p>
+            <a:pPr algn="l">
+              <a:spcAft>
+                <a:spcPts val="700"/>
+              </a:spcAft>
+            </a:pPr>
+            <a:r>
+              <a:rPr sz="1350" b="1" i="0">
                 <a:solidFill>
                   <a:srgbClr val="1B7837"/>
                 </a:solidFill>
@@ -8232,23 +8666,23 @@
               <a:t>•  </a:t>
             </a:r>
             <a:r>
-              <a:rPr sz="1300" b="0">
+              <a:rPr sz="1350" b="0" i="0">
                 <a:solidFill>
                   <a:srgbClr val="555555"/>
                 </a:solidFill>
                 <a:latin typeface="Calibri"/>
               </a:rPr>
-              <a:t>at least 40 annual observations, 10+ years on each side of the break, break 10+ years from the boundary</a:t>
-            </a:r>
-          </a:p>
-          <a:p>
-            <a:pPr algn="l">
-              <a:spcAft>
-                <a:spcPts val="500"/>
-              </a:spcAft>
-            </a:pPr>
-            <a:r>
-              <a:rPr sz="1300" b="1">
+              <a:t>the series is long enough (40+ years, with at least 10 on each side of the break);</a:t>
+            </a:r>
+          </a:p>
+          <a:p>
+            <a:pPr algn="l">
+              <a:spcAft>
+                <a:spcPts val="700"/>
+              </a:spcAft>
+            </a:pPr>
+            <a:r>
+              <a:rPr sz="1350" b="1" i="0">
                 <a:solidFill>
                   <a:srgbClr val="1B7837"/>
                 </a:solidFill>
@@ -8257,23 +8691,23 @@
               <a:t>•  </a:t>
             </a:r>
             <a:r>
-              <a:rPr sz="1300" b="0">
+              <a:rPr sz="1350" b="0" i="0">
                 <a:solidFill>
                   <a:srgbClr val="555555"/>
                 </a:solidFill>
                 <a:latin typeface="Calibri"/>
               </a:rPr>
-              <a:t>BIC improvement of at least 6 over the unbroken trend</a:t>
-            </a:r>
-          </a:p>
-          <a:p>
-            <a:pPr algn="l">
-              <a:spcAft>
-                <a:spcPts val="500"/>
-              </a:spcAft>
-            </a:pPr>
-            <a:r>
-              <a:rPr sz="1300" b="1">
+              <a:t>the two-line model fits clearly better than a single straight line;</a:t>
+            </a:r>
+          </a:p>
+          <a:p>
+            <a:pPr algn="l">
+              <a:spcAft>
+                <a:spcPts val="700"/>
+              </a:spcAft>
+            </a:pPr>
+            <a:r>
+              <a:rPr sz="1350" b="1" i="0">
                 <a:solidFill>
                   <a:srgbClr val="1B7837"/>
                 </a:solidFill>
@@ -8282,23 +8716,23 @@
               <a:t>•  </a:t>
             </a:r>
             <a:r>
-              <a:rPr sz="1300" b="0">
+              <a:rPr sz="1350" b="0" i="0">
                 <a:solidFill>
                   <a:srgbClr val="555555"/>
                 </a:solidFill>
                 <a:latin typeface="Calibri"/>
               </a:rPr>
-              <a:t>70%+ of bootstrap dates within 5 years; interval no wider than 12 years</a:t>
-            </a:r>
-          </a:p>
-          <a:p>
-            <a:pPr algn="l">
-              <a:spcAft>
-                <a:spcPts val="500"/>
-              </a:spcAft>
-            </a:pPr>
-            <a:r>
-              <a:rPr sz="1300" b="1">
+              <a:t>the estimated year stays put when the data are reshuffled; and</a:t>
+            </a:r>
+          </a:p>
+          <a:p>
+            <a:pPr algn="l">
+              <a:spcAft>
+                <a:spcPts val="700"/>
+              </a:spcAft>
+            </a:pPr>
+            <a:r>
+              <a:rPr sz="1350" b="1" i="0">
                 <a:solidFill>
                   <a:srgbClr val="1B7837"/>
                 </a:solidFill>
@@ -8307,73 +8741,213 @@
               <a:t>•  </a:t>
             </a:r>
             <a:r>
-              <a:rPr sz="1300" b="0">
+              <a:rPr sz="1350" b="0" i="0">
                 <a:solidFill>
                   <a:srgbClr val="555555"/>
                 </a:solidFill>
                 <a:latin typeface="Calibri"/>
               </a:rPr>
-              <a:t>standardized slope change of at least 0.25</a:t>
-            </a:r>
-          </a:p>
-          <a:p>
-            <a:pPr algn="l">
-              <a:spcAft>
-                <a:spcPts val="800"/>
-              </a:spcAft>
-            </a:pPr>
-            <a:r>
-              <a:rPr sz="1300" b="0" i="0">
+              <a:t>the change in slope is big enough to matter, not a statistical whisker.</a:t>
+            </a:r>
+          </a:p>
+          <a:p>
+            <a:pPr algn="l">
+              <a:spcAft>
+                <a:spcPts val="0"/>
+              </a:spcAft>
+            </a:pPr>
+            <a:r>
+              <a:rPr sz="1350" b="0" i="0">
                 <a:solidFill>
                   <a:srgbClr val="212121"/>
                 </a:solidFill>
                 <a:latin typeface="Calibri"/>
               </a:rPr>
-              <a:t>204 jurisdictions → 158 estimable → 97 countries with an eligible, stable headline break; nearby component breaks consolidate into 107 transition episodes (15-year grouping; 10/20-year sensitivity).</a:t>
-            </a:r>
-          </a:p>
-          <a:p>
-            <a:pPr algn="l">
-              <a:spcAft>
-                <a:spcPts val="0"/>
-              </a:spcAft>
-            </a:pPr>
-            <a:r>
-              <a:rPr sz="1300" b="1" i="0">
-                <a:solidFill>
-                  <a:srgbClr val="212121"/>
-                </a:solidFill>
-                <a:latin typeface="Calibri"/>
-              </a:rPr>
-              <a:t>Treaty attribution ladder (all five required): Newey–West significance → top 10% vs nearby placebo dates → best date within 3 years of the treaty → compatible unrestricted break → plausible domestic mechanism.</a:t>
-            </a:r>
-          </a:p>
-        </p:txBody>
-      </p:sp>
-      <p:pic>
-        <p:nvPicPr>
-          <p:cNvPr id="4" name="Picture 3" descr="image1.png"/>
-          <p:cNvPicPr>
-            <a:picLocks noChangeAspect="1"/>
-          </p:cNvPicPr>
+              <a:t>204 jurisdictions → 158 with estimable series → 97 countries with a break that passes every test. Breaks close together in time are read as one national transition: 107 episodes in all.</a:t>
+            </a:r>
+          </a:p>
+        </p:txBody>
+      </p:sp>
+      <p:sp>
+        <p:nvSpPr>
+          <p:cNvPr id="4" name="TextBox 3"/>
+          <p:cNvSpPr txBox="1"/>
           <p:nvPr/>
-        </p:nvPicPr>
-        <p:blipFill>
-          <a:blip r:embed="rId2"/>
-          <a:stretch>
-            <a:fillRect/>
-          </a:stretch>
-        </p:blipFill>
+        </p:nvSpPr>
         <p:spPr>
           <a:xfrm>
-            <a:off x="5623560" y="2835783"/>
-            <a:ext cx="6263640" cy="2192274"/>
+            <a:off x="5806440" y="1417320"/>
+            <a:ext cx="5897880" cy="5029200"/>
           </a:xfrm>
           <a:prstGeom prst="rect">
             <a:avLst/>
           </a:prstGeom>
+          <a:noFill/>
         </p:spPr>
-      </p:pic>
+        <p:txBody>
+          <a:bodyPr wrap="square">
+            <a:spAutoFit/>
+          </a:bodyPr>
+          <a:lstStyle/>
+          <a:p>
+            <a:pPr algn="l">
+              <a:spcAft>
+                <a:spcPts val="800"/>
+              </a:spcAft>
+            </a:pPr>
+            <a:r>
+              <a:rPr sz="1550" b="1" i="0">
+                <a:solidFill>
+                  <a:srgbClr val="212121"/>
+                </a:solidFill>
+                <a:latin typeface="Calibri"/>
+              </a:rPr>
+              <a:t>A treaty year gets credit only if all five hold:</a:t>
+            </a:r>
+          </a:p>
+          <a:p>
+            <a:pPr algn="l">
+              <a:spcAft>
+                <a:spcPts val="700"/>
+              </a:spcAft>
+            </a:pPr>
+            <a:r>
+              <a:rPr sz="1350" b="1" i="0">
+                <a:solidFill>
+                  <a:srgbClr val="3A66A5"/>
+                </a:solidFill>
+                <a:latin typeface="Calibri"/>
+              </a:rPr>
+              <a:t>1.  </a:t>
+            </a:r>
+            <a:r>
+              <a:rPr sz="1350" b="0" i="0">
+                <a:solidFill>
+                  <a:srgbClr val="555555"/>
+                </a:solidFill>
+                <a:latin typeface="Calibri"/>
+              </a:rPr>
+              <a:t>the slope genuinely changes at the treaty year (by a robust statistical test);</a:t>
+            </a:r>
+          </a:p>
+          <a:p>
+            <a:pPr algn="l">
+              <a:spcAft>
+                <a:spcPts val="700"/>
+              </a:spcAft>
+            </a:pPr>
+            <a:r>
+              <a:rPr sz="1350" b="1" i="0">
+                <a:solidFill>
+                  <a:srgbClr val="3A66A5"/>
+                </a:solidFill>
+                <a:latin typeface="Calibri"/>
+              </a:rPr>
+              <a:t>2.  </a:t>
+            </a:r>
+            <a:r>
+              <a:rPr sz="1350" b="0" i="0">
+                <a:solidFill>
+                  <a:srgbClr val="555555"/>
+                </a:solidFill>
+                <a:latin typeface="Calibri"/>
+              </a:rPr>
+              <a:t>the treaty year beats nearly all nearby 'placebo' years — because when a trend curves gently, almost any year looks significant;</a:t>
+            </a:r>
+          </a:p>
+          <a:p>
+            <a:pPr algn="l">
+              <a:spcAft>
+                <a:spcPts val="700"/>
+              </a:spcAft>
+            </a:pPr>
+            <a:r>
+              <a:rPr sz="1350" b="1" i="0">
+                <a:solidFill>
+                  <a:srgbClr val="3A66A5"/>
+                </a:solidFill>
+                <a:latin typeface="Calibri"/>
+              </a:rPr>
+              <a:t>3.  </a:t>
+            </a:r>
+            <a:r>
+              <a:rPr sz="1350" b="0" i="0">
+                <a:solidFill>
+                  <a:srgbClr val="555555"/>
+                </a:solidFill>
+                <a:latin typeface="Calibri"/>
+              </a:rPr>
+              <a:t>the best-fitting year is within three years of the treaty;</a:t>
+            </a:r>
+          </a:p>
+          <a:p>
+            <a:pPr algn="l">
+              <a:spcAft>
+                <a:spcPts val="700"/>
+              </a:spcAft>
+            </a:pPr>
+            <a:r>
+              <a:rPr sz="1350" b="1" i="0">
+                <a:solidFill>
+                  <a:srgbClr val="3A66A5"/>
+                </a:solidFill>
+                <a:latin typeface="Calibri"/>
+              </a:rPr>
+              <a:t>4.  </a:t>
+            </a:r>
+            <a:r>
+              <a:rPr sz="1350" b="0" i="0">
+                <a:solidFill>
+                  <a:srgbClr val="555555"/>
+                </a:solidFill>
+                <a:latin typeface="Calibri"/>
+              </a:rPr>
+              <a:t>the data-chosen break agrees with it; and</a:t>
+            </a:r>
+          </a:p>
+          <a:p>
+            <a:pPr algn="l">
+              <a:spcAft>
+                <a:spcPts val="700"/>
+              </a:spcAft>
+            </a:pPr>
+            <a:r>
+              <a:rPr sz="1350" b="1" i="0">
+                <a:solidFill>
+                  <a:srgbClr val="3A66A5"/>
+                </a:solidFill>
+                <a:latin typeface="Calibri"/>
+              </a:rPr>
+              <a:t>5.  </a:t>
+            </a:r>
+            <a:r>
+              <a:rPr sz="1350" b="0" i="0">
+                <a:solidFill>
+                  <a:srgbClr val="555555"/>
+                </a:solidFill>
+                <a:latin typeface="Calibri"/>
+              </a:rPr>
+              <a:t>there is a documented domestic policy story that fits.</a:t>
+            </a:r>
+          </a:p>
+          <a:p>
+            <a:pPr algn="l">
+              <a:spcAft>
+                <a:spcPts val="0"/>
+              </a:spcAft>
+            </a:pPr>
+            <a:r>
+              <a:rPr sz="1350" b="1" i="0">
+                <a:solidFill>
+                  <a:srgbClr val="212121"/>
+                </a:solidFill>
+                <a:latin typeface="Calibri"/>
+              </a:rPr>
+              <a:t>This ladder is deliberately hard to climb. Many series pass step 1; few pass them all. We hold Paris itself to the same standard.</a:t>
+            </a:r>
+          </a:p>
+        </p:txBody>
+      </p:sp>
     </p:spTree>
   </p:cSld>
   <p:clrMapOvr>
@@ -8400,8 +8974,8 @@
         </p:nvSpPr>
         <p:spPr>
           <a:xfrm>
-            <a:off x="502920" y="256032"/>
-            <a:ext cx="11201400" cy="1051560"/>
+            <a:off x="502920" y="274320"/>
+            <a:ext cx="11201400" cy="914400"/>
           </a:xfrm>
           <a:prstGeom prst="rect">
             <a:avLst/>
@@ -8436,7 +9010,7 @@
               </a:spcAft>
             </a:pPr>
             <a:r>
-              <a:rPr sz="2700" b="1" i="0">
+              <a:rPr sz="2400" b="1" i="0">
                 <a:solidFill>
                   <a:srgbClr val="212121"/>
                 </a:solidFill>
@@ -8757,8 +9331,8 @@
         </p:nvSpPr>
         <p:spPr>
           <a:xfrm>
-            <a:off x="502920" y="256032"/>
-            <a:ext cx="11201400" cy="1051560"/>
+            <a:off x="502920" y="274320"/>
+            <a:ext cx="11201400" cy="914400"/>
           </a:xfrm>
           <a:prstGeom prst="rect">
             <a:avLst/>
@@ -8793,20 +9367,68 @@
               </a:spcAft>
             </a:pPr>
             <a:r>
-              <a:rPr sz="2700" b="1" i="0">
+              <a:rPr sz="2400" b="1" i="0">
                 <a:solidFill>
                   <a:srgbClr val="212121"/>
                 </a:solidFill>
                 <a:latin typeface="Calibri"/>
               </a:rPr>
-              <a:t>Global curves first bent in the 1970s — decades before the climate regime</a:t>
+              <a:t>Global curves first bent in the 1970s</a:t>
+            </a:r>
+          </a:p>
+        </p:txBody>
+      </p:sp>
+      <p:sp>
+        <p:nvSpPr>
+          <p:cNvPr id="3" name="TextBox 2"/>
+          <p:cNvSpPr txBox="1"/>
+          <p:nvPr/>
+        </p:nvSpPr>
+        <p:spPr>
+          <a:xfrm>
+            <a:off x="502920" y="1207008"/>
+            <a:ext cx="11201400" cy="603504"/>
+          </a:xfrm>
+          <a:prstGeom prst="rect">
+            <a:avLst/>
+          </a:prstGeom>
+          <a:noFill/>
+        </p:spPr>
+        <p:txBody>
+          <a:bodyPr wrap="square">
+            <a:spAutoFit/>
+          </a:bodyPr>
+          <a:lstStyle/>
+          <a:p>
+            <a:pPr algn="l">
+              <a:spcAft>
+                <a:spcPts val="0"/>
+              </a:spcAft>
+            </a:pPr>
+            <a:r>
+              <a:rPr sz="1250" b="1" i="0">
+                <a:solidFill>
+                  <a:srgbClr val="3A66A5"/>
+                </a:solidFill>
+                <a:latin typeface="Calibri"/>
+              </a:rPr>
+              <a:t>How to read it:  </a:t>
+            </a:r>
+            <a:r>
+              <a:rPr sz="1250" b="0" i="0">
+                <a:solidFill>
+                  <a:srgbClr val="555555"/>
+                </a:solidFill>
+                <a:latin typeface="Calibri"/>
+              </a:rPr>
+              <a:t>Gray dots are the world's CO2 per dollar of output each year (1965 = 100). The red line is the best-fitting pair of straight lines; where they meet — 1973 — is the estimated break. Rio and Paris are marked for comparison: both come long after the bend. The lower panel repeats the estimate for each component; the whiskers show how uncertain each break year is.</a:t>
             </a:r>
           </a:p>
         </p:txBody>
       </p:sp>
       <p:pic>
         <p:nvPicPr>
-          <p:cNvPr id="3" name="Picture 2" descr="takeaway_fig01_global_bend_predates_treaties.png"/>
+          <p:cNvPr id="4" name="Picture 3" descr="takeaway_fig01_global_bend_predates_treaties.png"/>
           <p:cNvPicPr>
             <a:picLocks noChangeAspect="1"/>
           </p:cNvPicPr>
@@ -8820,8 +9442,8 @@
         </p:blipFill>
         <p:spPr>
           <a:xfrm>
-            <a:off x="2854612" y="1325879"/>
-            <a:ext cx="6479727" cy="5129784"/>
+            <a:off x="3102944" y="1865376"/>
+            <a:ext cx="5983063" cy="4736592"/>
           </a:xfrm>
           <a:prstGeom prst="rect">
             <a:avLst/>
@@ -8854,8 +9476,8 @@
         </p:nvSpPr>
         <p:spPr>
           <a:xfrm>
-            <a:off x="502920" y="256032"/>
-            <a:ext cx="11201400" cy="1051560"/>
+            <a:off x="502920" y="274320"/>
+            <a:ext cx="11201400" cy="914400"/>
           </a:xfrm>
           <a:prstGeom prst="rect">
             <a:avLst/>
@@ -8890,20 +9512,68 @@
               </a:spcAft>
             </a:pPr>
             <a:r>
-              <a:rPr sz="2700" b="1" i="0">
+              <a:rPr sz="2400" b="1" i="0">
                 <a:solidFill>
                   <a:srgbClr val="212121"/>
                 </a:solidFill>
                 <a:latin typeface="Calibri"/>
               </a:rPr>
-              <a:t>Paris at ten: intensity is outrunning its old trend — but the bend began earlier</a:t>
+              <a:t>Paris at ten: ahead of trend — but the bend began earlier</a:t>
+            </a:r>
+          </a:p>
+        </p:txBody>
+      </p:sp>
+      <p:sp>
+        <p:nvSpPr>
+          <p:cNvPr id="3" name="TextBox 2"/>
+          <p:cNvSpPr txBox="1"/>
+          <p:nvPr/>
+        </p:nvSpPr>
+        <p:spPr>
+          <a:xfrm>
+            <a:off x="502920" y="1207008"/>
+            <a:ext cx="11201400" cy="603504"/>
+          </a:xfrm>
+          <a:prstGeom prst="rect">
+            <a:avLst/>
+          </a:prstGeom>
+          <a:noFill/>
+        </p:spPr>
+        <p:txBody>
+          <a:bodyPr wrap="square">
+            <a:spAutoFit/>
+          </a:bodyPr>
+          <a:lstStyle/>
+          <a:p>
+            <a:pPr algn="l">
+              <a:spcAft>
+                <a:spcPts val="0"/>
+              </a:spcAft>
+            </a:pPr>
+            <a:r>
+              <a:rPr sz="1250" b="1" i="0">
+                <a:solidFill>
+                  <a:srgbClr val="3A66A5"/>
+                </a:solidFill>
+                <a:latin typeface="Calibri"/>
+              </a:rPr>
+              <a:t>How to read it:  </a:t>
+            </a:r>
+            <a:r>
+              <a:rPr sz="1250" b="0" i="0">
+                <a:solidFill>
+                  <a:srgbClr val="555555"/>
+                </a:solidFill>
+                <a:latin typeface="Calibri"/>
+              </a:rPr>
+              <a:t>We draw the 1990–2015 trend, then extend it past Paris (dashed line) with a band showing where future years should fall if nothing changed. Red dots are the actual years since Paris. Dots below the band mean the world is now improving faster than its old trend — clearly so for the fuel mix, not at all for energy efficiency.</a:t>
             </a:r>
           </a:p>
         </p:txBody>
       </p:sp>
       <p:pic>
         <p:nvPicPr>
-          <p:cNvPr id="3" name="Picture 2" descr="takeaway_fig02a_paris_and_the_long_trend.png"/>
+          <p:cNvPr id="4" name="Picture 3" descr="takeaway_fig02a_paris_and_the_long_trend.png"/>
           <p:cNvPicPr>
             <a:picLocks noChangeAspect="1"/>
           </p:cNvPicPr>
@@ -8917,8 +9587,8 @@
         </p:blipFill>
         <p:spPr>
           <a:xfrm>
-            <a:off x="537210" y="1325880"/>
-            <a:ext cx="11114532" cy="5129783"/>
+            <a:off x="963168" y="1865376"/>
+            <a:ext cx="10262616" cy="4736592"/>
           </a:xfrm>
           <a:prstGeom prst="rect">
             <a:avLst/>
@@ -8951,8 +9621,8 @@
         </p:nvSpPr>
         <p:spPr>
           <a:xfrm>
-            <a:off x="502920" y="256032"/>
-            <a:ext cx="11201400" cy="1051560"/>
+            <a:off x="502920" y="274320"/>
+            <a:ext cx="11201400" cy="914400"/>
           </a:xfrm>
           <a:prstGeom prst="rect">
             <a:avLst/>
@@ -8987,20 +9657,68 @@
               </a:spcAft>
             </a:pPr>
             <a:r>
-              <a:rPr sz="2700" b="1" i="0">
+              <a:rPr sz="2400" b="1" i="0">
                 <a:solidFill>
                   <a:srgbClr val="212121"/>
                 </a:solidFill>
                 <a:latin typeface="Calibri"/>
               </a:rPr>
-              <a:t>The arithmetic of bending the curve: intensity must fall as fast as GDP grows</a:t>
+              <a:t>The arithmetic: intensity must fall as fast as GDP grows</a:t>
+            </a:r>
+          </a:p>
+        </p:txBody>
+      </p:sp>
+      <p:sp>
+        <p:nvSpPr>
+          <p:cNvPr id="3" name="TextBox 2"/>
+          <p:cNvSpPr txBox="1"/>
+          <p:nvPr/>
+        </p:nvSpPr>
+        <p:spPr>
+          <a:xfrm>
+            <a:off x="502920" y="1207008"/>
+            <a:ext cx="11201400" cy="603504"/>
+          </a:xfrm>
+          <a:prstGeom prst="rect">
+            <a:avLst/>
+          </a:prstGeom>
+          <a:noFill/>
+        </p:spPr>
+        <p:txBody>
+          <a:bodyPr wrap="square">
+            <a:spAutoFit/>
+          </a:bodyPr>
+          <a:lstStyle/>
+          <a:p>
+            <a:pPr algn="l">
+              <a:spcAft>
+                <a:spcPts val="0"/>
+              </a:spcAft>
+            </a:pPr>
+            <a:r>
+              <a:rPr sz="1250" b="1" i="0">
+                <a:solidFill>
+                  <a:srgbClr val="3A66A5"/>
+                </a:solidFill>
+                <a:latin typeface="Calibri"/>
+              </a:rPr>
+              <a:t>How to read it:  </a:t>
+            </a:r>
+            <a:r>
+              <a:rPr sz="1250" b="0" i="0">
+                <a:solidFill>
+                  <a:srgbClr val="555555"/>
+                </a:solidFill>
+                <a:latin typeface="Calibri"/>
+              </a:rPr>
+              <a:t>Each bar is an average annual growth rate. By construction, the red emissions bar equals the gray GDP bar plus the two colored intensity bars. Emissions stop growing only when the colored bars together are as long as the gray one — the dotted line marks that target. We are closer than before Paris, but not there.</a:t>
             </a:r>
           </a:p>
         </p:txBody>
       </p:sp>
       <p:pic>
         <p:nvPicPr>
-          <p:cNvPr id="3" name="Picture 2" descr="takeaway_fig02b_stabilization_arithmetic.png"/>
+          <p:cNvPr id="4" name="Picture 3" descr="takeaway_fig02b_stabilization_arithmetic.png"/>
           <p:cNvPicPr>
             <a:picLocks noChangeAspect="1"/>
           </p:cNvPicPr>
@@ -9014,8 +9732,8 @@
         </p:blipFill>
         <p:spPr>
           <a:xfrm>
-            <a:off x="537210" y="1325880"/>
-            <a:ext cx="11114532" cy="5129783"/>
+            <a:off x="963168" y="1865376"/>
+            <a:ext cx="10262616" cy="4736592"/>
           </a:xfrm>
           <a:prstGeom prst="rect">
             <a:avLst/>
@@ -9048,8 +9766,8 @@
         </p:nvSpPr>
         <p:spPr>
           <a:xfrm>
-            <a:off x="502920" y="256032"/>
-            <a:ext cx="11201400" cy="1051560"/>
+            <a:off x="502920" y="274320"/>
+            <a:ext cx="11201400" cy="914400"/>
           </a:xfrm>
           <a:prstGeom prst="rect">
             <a:avLst/>
@@ -9084,20 +9802,68 @@
               </a:spcAft>
             </a:pPr>
             <a:r>
-              <a:rPr sz="2700" b="1" i="0">
+              <a:rPr sz="2400" b="1" i="0">
                 <a:solidFill>
                   <a:srgbClr val="212121"/>
                 </a:solidFill>
                 <a:latin typeface="Calibri"/>
               </a:rPr>
-              <a:t>The placebo discipline: many years look like turning points</a:t>
+              <a:t>Why a treaty-year result needs a placebo test</a:t>
+            </a:r>
+          </a:p>
+        </p:txBody>
+      </p:sp>
+      <p:sp>
+        <p:nvSpPr>
+          <p:cNvPr id="3" name="TextBox 2"/>
+          <p:cNvSpPr txBox="1"/>
+          <p:nvPr/>
+        </p:nvSpPr>
+        <p:spPr>
+          <a:xfrm>
+            <a:off x="502920" y="1207008"/>
+            <a:ext cx="11201400" cy="603504"/>
+          </a:xfrm>
+          <a:prstGeom prst="rect">
+            <a:avLst/>
+          </a:prstGeom>
+          <a:noFill/>
+        </p:spPr>
+        <p:txBody>
+          <a:bodyPr wrap="square">
+            <a:spAutoFit/>
+          </a:bodyPr>
+          <a:lstStyle/>
+          <a:p>
+            <a:pPr algn="l">
+              <a:spcAft>
+                <a:spcPts val="0"/>
+              </a:spcAft>
+            </a:pPr>
+            <a:r>
+              <a:rPr sz="1250" b="1" i="0">
+                <a:solidFill>
+                  <a:srgbClr val="3A66A5"/>
+                </a:solidFill>
+                <a:latin typeface="Calibri"/>
+              </a:rPr>
+              <a:t>How to read it:  </a:t>
+            </a:r>
+            <a:r>
+              <a:rPr sz="1250" b="0" i="0">
+                <a:solidFill>
+                  <a:srgbClr val="555555"/>
+                </a:solidFill>
+                <a:latin typeface="Calibri"/>
+              </a:rPr>
+              <a:t>Top: we place the break at every possible year, one at a time, and record how much better the model fits. Rio fits well — but so do many neighboring years, which is why a good fit at a treaty year proves little on its own. Bottom: the share of country series with a significant change at each treaty year (left point) versus the share where the treaty year also beats its neighbors (right point).</a:t>
             </a:r>
           </a:p>
         </p:txBody>
       </p:sp>
       <p:pic>
         <p:nvPicPr>
-          <p:cNvPr id="3" name="Picture 2" descr="takeaway_fig02_placebo_test.png"/>
+          <p:cNvPr id="4" name="Picture 3" descr="takeaway_fig02_placebo_test.png"/>
           <p:cNvPicPr>
             <a:picLocks noChangeAspect="1"/>
           </p:cNvPicPr>
@@ -9111,8 +9877,8 @@
         </p:blipFill>
         <p:spPr>
           <a:xfrm>
-            <a:off x="3016605" y="1325880"/>
-            <a:ext cx="6155740" cy="5129783"/>
+            <a:off x="3252520" y="1865376"/>
+            <a:ext cx="5683910" cy="4736592"/>
           </a:xfrm>
           <a:prstGeom prst="rect">
             <a:avLst/>

</xml_diff>